<commit_message>
feat(data): add Madhva mukti-gradations — sālokya, sāmīpya, sārūpya, sāyujya
Four new concept nodes in the phala tier capture Madhva's distinctive doctrine that mokṣa has tāratamya — liberated jīvas attain different grades of nearness to Hari, never identity. Communion (sāyujya) at the top, co-residence (sālokya) at the foot of the ascent.

8 new edges wire the gradations into the existing phala graph (moksha includes each grade; ascending leads-to chain; sayujya is-a paramagati). Hand-laid positions cluster the four grades around moksha in the celestial map. Decks regenerated.

Audit clean: 96 nodes / 99 edges / 42 shlokas / 20 Madhva-distinctive callouts / 12 tiers.
</commit_message>
<xml_diff>
--- a/decks/Bhagavadgita_Concept_KG_dev.pptx
+++ b/decks/Bhagavadgita_Concept_KG_dev.pptx
@@ -2360,7 +2360,7 @@
                 <a:ea typeface="Arial" pitchFamily="34" charset="-122"/>
                 <a:cs typeface="Arial" pitchFamily="34" charset="-120"/>
               </a:rPr>
-              <a:t>92 concepts · 101 relations · 12 tiers</a:t>
+              <a:t>96 concepts · 99 relations · 12 tiers</a:t>
             </a:r>
             <a:endParaRPr lang="en-US" sz="1200" dirty="0"/>
           </a:p>
@@ -3677,7 +3677,7 @@
                 <a:ea typeface="Cambria" pitchFamily="34" charset="-122"/>
                 <a:cs typeface="Cambria" pitchFamily="34" charset="-120"/>
               </a:rPr>
-              <a:t>92</a:t>
+              <a:t>96</a:t>
             </a:r>
             <a:endParaRPr lang="en-US" sz="6400" dirty="0"/>
           </a:p>
@@ -3833,7 +3833,7 @@
                 <a:ea typeface="Cambria" pitchFamily="34" charset="-122"/>
                 <a:cs typeface="Cambria" pitchFamily="34" charset="-120"/>
               </a:rPr>
-              <a:t>101</a:t>
+              <a:t>99</a:t>
             </a:r>
             <a:endParaRPr lang="en-US" sz="6400" dirty="0"/>
           </a:p>
@@ -4126,7 +4126,7 @@
                 <a:ea typeface="Arial" pitchFamily="34" charset="-122"/>
                 <a:cs typeface="Arial" pitchFamily="34" charset="-120"/>
               </a:rPr>
-              <a:t>92 concept nodes</a:t>
+              <a:t>96 concept nodes</a:t>
             </a:r>
             <a:endParaRPr lang="en-US" sz="1800" dirty="0"/>
           </a:p>
@@ -4145,7 +4145,7 @@
                 <a:ea typeface="Arial" pitchFamily="34" charset="-122"/>
                 <a:cs typeface="Arial" pitchFamily="34" charset="-120"/>
               </a:rPr>
-              <a:t>101 typed relations</a:t>
+              <a:t>99 typed relations</a:t>
             </a:r>
             <a:endParaRPr lang="en-US" sz="1800" dirty="0"/>
           </a:p>
@@ -4202,7 +4202,7 @@
                 <a:ea typeface="Arial" pitchFamily="34" charset="-122"/>
                 <a:cs typeface="Arial" pitchFamily="34" charset="-120"/>
               </a:rPr>
-              <a:t>16 Madhva-distinctive callouts</a:t>
+              <a:t>20 Madhva-distinctive callouts</a:t>
             </a:r>
             <a:endParaRPr lang="en-US" sz="1800" dirty="0"/>
           </a:p>
@@ -9911,7 +9911,7 @@
                 <a:ea typeface="Arial" pitchFamily="34" charset="-122"/>
                 <a:cs typeface="Arial" pitchFamily="34" charset="-120"/>
               </a:rPr>
-              <a:t>8</a:t>
+              <a:t>12</a:t>
             </a:r>
             <a:endParaRPr lang="en-US" sz="1400" dirty="0"/>
           </a:p>

</xml_diff>

<commit_message>
feat(data): jñāna-aṅgas (Ch 13), three-fold faith/food (Ch 17), pravṛtti-nivṛtti (Ch 18), tāratamya & pañca-bheda (Madhva schemata)
16 new concept nodes + 26 new edges:

 · Paramārtha: tāratamya, pañca-bheda (Madhva-defining schemata)

 · Sādhanā: jñāna-aṅgas umbrella + 7 of the 20 (amānitva, ārjava, śauca, kṣānti, ananya-yoga, vivikta-sevā, adhyātma-jñāna-nityatvam, tattva-jñānārtha-darśanam)

 · Guṇa: threefold śraddhā (sāttvika/rājasa/tāmasa) + sāttvika āhāra from Ch 17

 · Dharma: pravṛtti-nivṛtti — the dual knowing of sāttvika buddhi (18.30)

Now 112 concepts / 124 edges / 22 Madhva-distinctive callouts. Decks regenerated.
</commit_message>
<xml_diff>
--- a/decks/Bhagavadgita_Concept_KG_dev.pptx
+++ b/decks/Bhagavadgita_Concept_KG_dev.pptx
@@ -2360,7 +2360,7 @@
                 <a:ea typeface="Arial" pitchFamily="34" charset="-122"/>
                 <a:cs typeface="Arial" pitchFamily="34" charset="-120"/>
               </a:rPr>
-              <a:t>96 concepts · 99 relations · 12 tiers</a:t>
+              <a:t>112 concepts · 124 relations · 12 tiers</a:t>
             </a:r>
             <a:endParaRPr lang="en-US" sz="1200" dirty="0"/>
           </a:p>
@@ -3677,7 +3677,7 @@
                 <a:ea typeface="Cambria" pitchFamily="34" charset="-122"/>
                 <a:cs typeface="Cambria" pitchFamily="34" charset="-120"/>
               </a:rPr>
-              <a:t>96</a:t>
+              <a:t>112</a:t>
             </a:r>
             <a:endParaRPr lang="en-US" sz="6400" dirty="0"/>
           </a:p>
@@ -3833,7 +3833,7 @@
                 <a:ea typeface="Cambria" pitchFamily="34" charset="-122"/>
                 <a:cs typeface="Cambria" pitchFamily="34" charset="-120"/>
               </a:rPr>
-              <a:t>99</a:t>
+              <a:t>124</a:t>
             </a:r>
             <a:endParaRPr lang="en-US" sz="6400" dirty="0"/>
           </a:p>
@@ -4126,7 +4126,7 @@
                 <a:ea typeface="Arial" pitchFamily="34" charset="-122"/>
                 <a:cs typeface="Arial" pitchFamily="34" charset="-120"/>
               </a:rPr>
-              <a:t>96 concept nodes</a:t>
+              <a:t>112 concept nodes</a:t>
             </a:r>
             <a:endParaRPr lang="en-US" sz="1800" dirty="0"/>
           </a:p>
@@ -4145,7 +4145,7 @@
                 <a:ea typeface="Arial" pitchFamily="34" charset="-122"/>
                 <a:cs typeface="Arial" pitchFamily="34" charset="-120"/>
               </a:rPr>
-              <a:t>99 typed relations</a:t>
+              <a:t>124 typed relations</a:t>
             </a:r>
             <a:endParaRPr lang="en-US" sz="1800" dirty="0"/>
           </a:p>
@@ -4202,7 +4202,7 @@
                 <a:ea typeface="Arial" pitchFamily="34" charset="-122"/>
                 <a:cs typeface="Arial" pitchFamily="34" charset="-120"/>
               </a:rPr>
-              <a:t>20 Madhva-distinctive callouts</a:t>
+              <a:t>22 Madhva-distinctive callouts</a:t>
             </a:r>
             <a:endParaRPr lang="en-US" sz="1800" dirty="0"/>
           </a:p>
@@ -8984,7 +8984,7 @@
                 <a:ea typeface="Arial" pitchFamily="34" charset="-122"/>
                 <a:cs typeface="Arial" pitchFamily="34" charset="-120"/>
               </a:rPr>
-              <a:t>8</a:t>
+              <a:t>10</a:t>
             </a:r>
             <a:endParaRPr lang="en-US" sz="1400" dirty="0"/>
           </a:p>
@@ -9293,7 +9293,7 @@
                 <a:ea typeface="Arial" pitchFamily="34" charset="-122"/>
                 <a:cs typeface="Arial" pitchFamily="34" charset="-120"/>
               </a:rPr>
-              <a:t>8</a:t>
+              <a:t>12</a:t>
             </a:r>
             <a:endParaRPr lang="en-US" sz="1400" dirty="0"/>
           </a:p>
@@ -9499,7 +9499,7 @@
                 <a:ea typeface="Arial" pitchFamily="34" charset="-122"/>
                 <a:cs typeface="Arial" pitchFamily="34" charset="-120"/>
               </a:rPr>
-              <a:t>9</a:t>
+              <a:t>18</a:t>
             </a:r>
             <a:endParaRPr lang="en-US" sz="1400" dirty="0"/>
           </a:p>
@@ -9705,7 +9705,7 @@
                 <a:ea typeface="Arial" pitchFamily="34" charset="-122"/>
                 <a:cs typeface="Arial" pitchFamily="34" charset="-120"/>
               </a:rPr>
-              <a:t>8</a:t>
+              <a:t>9</a:t>
             </a:r>
             <a:endParaRPr lang="en-US" sz="1400" dirty="0"/>
           </a:p>

</xml_diff>

<commit_message>
Rebuild docx and pptx from updated data sources
- Rebuilt Bhagavad_Gita_All_Verses_CLEAN.docx (702 verses, all 18 chapters)
  from _extracted/clean_verses_700.json; fixed hardcoded C:\Claude path
  in build_docx.py to use correct workspace path
- Rebuilt all 4 concept KG decks from current data.js:
    Bhagavadgita_Concept_KG_en.pptx  (EN - 533 KB)
    Bhagavadgita_Concept_KG_dev.pptx (DEV - 569 KB, now uses clean Sanskrit)
    Bhagavadgita_Concept_KG_kn.pptx  (KN - 560 KB)
    Bhagavadgita_Concept_KG_hi.pptx  (HI - 568 KB)
- Fixed data.js module.exports to include TIER_COLOR (was missing,
  causing TypeError in build-decks.js)
</commit_message>
<xml_diff>
--- a/decks/Bhagavadgita_Concept_KG_dev.pptx
+++ b/decks/Bhagavadgita_Concept_KG_dev.pptx
@@ -3385,7 +3385,7 @@
                 <a:ea typeface="Tiro Devanagari Sanskrit" pitchFamily="34" charset="-122"/>
                 <a:cs typeface="Tiro Devanagari Sanskrit" pitchFamily="34" charset="-120"/>
               </a:rPr>
-              <a:t>अन्तःकरण</a:t>
+              <a:t>à¤…à¤¨à¥à¤¤à¤ƒà¤•à¤°à¤£</a:t>
             </a:r>
             <a:endParaRPr lang="en-US" sz="3000" dirty="0"/>
           </a:p>
@@ -3516,7 +3516,7 @@
                 <a:ea typeface="Tiro Devanagari Sanskrit" pitchFamily="34" charset="-122"/>
                 <a:cs typeface="Tiro Devanagari Sanskrit" pitchFamily="34" charset="-120"/>
               </a:rPr>
-              <a:t>अन्तर्यामी — हृदये हरिः</a:t>
+              <a:t>à¤…à¤¨à¥à¤¤à¤°à¥à¤¯à¤¾à¤®à¥€ â€” à¤¹à¥ƒà¤¦à¤¯à¥‡ à¤¹à¤°à¤¿à¤ƒ</a:t>
             </a:r>
             <a:endParaRPr lang="en-US" sz="1300" dirty="0"/>
           </a:p>
@@ -3597,7 +3597,7 @@
                 <a:ea typeface="Tiro Devanagari Sanskrit" pitchFamily="34" charset="-122"/>
                 <a:cs typeface="Tiro Devanagari Sanskrit" pitchFamily="34" charset="-120"/>
               </a:rPr>
-              <a:t>"ईश्वरः सर्व-भूतानां हृद्देशेऽर्जुन तिष्ठति" — भगवान् सर्वेषां प्राणिनां हृदये स्थित्वा तान् सञ्चालयति।</a:t>
+              <a:t>"à¤ˆà¤¶à¥à¤µà¤°à¤ƒ à¤¸à¤°à¥à¤µ-à¤­à¥‚à¤¤à¤¾à¤¨à¤¾à¤‚ à¤¹à¥ƒà¤¦à¥à¤¦à¥‡à¤¶à¥‡à¤½à¤°à¥à¤œà¥à¤¨ à¤¤à¤¿à¤·à¥à¤ à¤¤à¤¿" â€” à¤­à¤—à¤µà¤¾à¤¨à¥ à¤¸à¤°à¥à¤µà¥‡à¤·à¤¾à¤‚ à¤ªà¥à¤°à¤¾à¤£à¤¿à¤¨à¤¾à¤‚ à¤¹à¥ƒà¤¦à¤¯à¥‡ à¤¸à¥à¤¥à¤¿à¤¤à¥à¤µà¤¾ à¤¤à¤¾à¤¨à¥ à¤¸à¤žà…</a:t>
             </a:r>
             <a:endParaRPr lang="en-US" sz="1050" dirty="0"/>
           </a:p>
@@ -3686,7 +3686,7 @@
                 <a:ea typeface="Tiro Devanagari Sanskrit" pitchFamily="34" charset="-122"/>
                 <a:cs typeface="Tiro Devanagari Sanskrit" pitchFamily="34" charset="-120"/>
               </a:rPr>
-              <a:t>मनस्</a:t>
+              <a:t>à¤®à¤¨à¤¸à¥</a:t>
             </a:r>
             <a:endParaRPr lang="en-US" sz="1300" dirty="0"/>
           </a:p>
@@ -3725,7 +3725,7 @@
                 <a:ea typeface="Cormorant Garamond" pitchFamily="34" charset="-122"/>
                 <a:cs typeface="Cormorant Garamond" pitchFamily="34" charset="-120"/>
               </a:rPr>
-              <a:t>BG 6.34–35 · 3.6–7</a:t>
+              <a:t>BG 6.34â€“35 Â· 3.6â€“7</a:t>
             </a:r>
             <a:endParaRPr lang="en-US" sz="950" dirty="0"/>
           </a:p>
@@ -3767,7 +3767,7 @@
                 <a:ea typeface="Tiro Devanagari Sanskrit" pitchFamily="34" charset="-122"/>
                 <a:cs typeface="Tiro Devanagari Sanskrit" pitchFamily="34" charset="-120"/>
               </a:rPr>
-              <a:t>एकादशम् इन्द्रियम्। चञ्चलं प्रमाथि दुर्निग्रहम् — तथापि कृष्णः कथयति यद् अभ्यासेन वैराग्येण च तद् निगृह्यते।</a:t>
+              <a:t>à¤à¤•à¤¾à¤¦à¤¶à¤®à¥ à¤‡à¤¨à¥à¤¦à¥à¤°à¤¿à¤¯à¤®à¥à¥¤ à¤šà¤žà¥à¤šà¤²à¤‚ à¤ªà¥à¤°à¤®à¤¾à¤¥à¤¿ à¤¦à¥à¤°à¥à¤¨à¤¿à¤—à¥à¤°à¤¹à¤®à¥ â€” à¤¤à¤¥à¤¾à¤ªà¤¿ à¤•à¥ƒà¤·à¥à¤£à¤ƒ à¤•à¤¥à¤¯à¤¤à¤¿ à¤¯à¤¦à¥ à¤…à¤­à¥à¤¯à¤¾à¤¸à¥‡à¤¨ à¤µà¥ˆà¤°à¤¾à¤—à¥à¤¯à¥‡à¤£ à¤š à¤…</a:t>
             </a:r>
             <a:endParaRPr lang="en-US" sz="1050" dirty="0"/>
           </a:p>
@@ -3856,7 +3856,7 @@
                 <a:ea typeface="Tiro Devanagari Sanskrit" pitchFamily="34" charset="-122"/>
                 <a:cs typeface="Tiro Devanagari Sanskrit" pitchFamily="34" charset="-120"/>
               </a:rPr>
-              <a:t>बुद्धिः</a:t>
+              <a:t>à¤¬à¥à¤¦à¥à¤§à¤¿à¤ƒ</a:t>
             </a:r>
             <a:endParaRPr lang="en-US" sz="1300" dirty="0"/>
           </a:p>
@@ -3895,7 +3895,7 @@
                 <a:ea typeface="Cormorant Garamond" pitchFamily="34" charset="-122"/>
                 <a:cs typeface="Cormorant Garamond" pitchFamily="34" charset="-120"/>
               </a:rPr>
-              <a:t>BG 18.30–32</a:t>
+              <a:t>BG 18.30â€“32</a:t>
             </a:r>
             <a:endParaRPr lang="en-US" sz="950" dirty="0"/>
           </a:p>
@@ -3937,7 +3937,7 @@
                 <a:ea typeface="Tiro Devanagari Sanskrit" pitchFamily="34" charset="-122"/>
                 <a:cs typeface="Tiro Devanagari Sanskrit" pitchFamily="34" charset="-120"/>
               </a:rPr>
-              <a:t>कार्याकार्य-विवेचनी वृत्तिः। साात्त्विकी बुद्धिः प्रवृत्तिं निवृत्तिं च जानाति।</a:t>
+              <a:t>à¤•à¤¾à¤°à¥à¤¯à¤¾à¤•à¤¾à¤°à¥à¤¯-à¤µà¤¿à¤µà¥‡à¤šà¤¨à¥€ à¤µà¥ƒà¤¤à¥à¤¤à¤¿à¤ƒà¥¤ à¤¸à¤¾à¤¾à¤¤à¥à¤¤à¥à¤µà¤¿à¤•à¥€ à¤¬à¥à¤¦à¥à¤§à¤¿à¤ƒ à¤ªà¥à¤°à¤µà¥ƒà¤¤à¥à¤¤à¤¿à¤‚ à¤¨à¤¿à¤µà¥ƒà¤¤à¥à¤¤à¤¿à¤‚ à¤š à¤œà¤¾à¤¨à¤¾à¤¤à¤¿à¥¤</a:t>
             </a:r>
             <a:endParaRPr lang="en-US" sz="1050" dirty="0"/>
           </a:p>
@@ -4026,7 +4026,7 @@
                 <a:ea typeface="Tiro Devanagari Sanskrit" pitchFamily="34" charset="-122"/>
                 <a:cs typeface="Tiro Devanagari Sanskrit" pitchFamily="34" charset="-120"/>
               </a:rPr>
-              <a:t>अहङ्कारः</a:t>
+              <a:t>à¤…à¤¹à¤™à¥à¤•à¤¾à¤°à¤ƒ</a:t>
             </a:r>
             <a:endParaRPr lang="en-US" sz="1300" dirty="0"/>
           </a:p>
@@ -4065,7 +4065,7 @@
                 <a:ea typeface="Cormorant Garamond" pitchFamily="34" charset="-122"/>
                 <a:cs typeface="Cormorant Garamond" pitchFamily="34" charset="-120"/>
               </a:rPr>
-              <a:t>BG 3.27 · 7.4</a:t>
+              <a:t>BG 3.27 Â· 7.4</a:t>
             </a:r>
             <a:endParaRPr lang="en-US" sz="950" dirty="0"/>
           </a:p>
@@ -4107,7 +4107,7 @@
                 <a:ea typeface="Tiro Devanagari Sanskrit" pitchFamily="34" charset="-122"/>
                 <a:cs typeface="Tiro Devanagari Sanskrit" pitchFamily="34" charset="-120"/>
               </a:rPr>
-              <a:t>कर्तृत्व-अभिमानः। "कर्ताहम् इति मन्यते" — अहङ्कार-विमूढात्मा पुरुषः स्वम् कर्तारं मन्यते।</a:t>
+              <a:t>à¤•à¤°à¥à¤¤à¥ƒà¤¤à¥à¤µ-à¤…à¤­à¤¿à¤®à¤¾à¤¨à¤ƒà¥¤ "à¤•à¤°à¥à¤¤à¤¾à¤¹à¤®à¥ à¤‡à¤¤à¤¿ à¤®à¤¨à¥à¤¯à¤¤à¥‡" â€” à¤…à¤¹à¤™à¥à¤•à¤¾à¤°-à¤µà¤¿à¤®à¥‚à¤¢à¤¾à¤¤à¥à¤®à¤¾ à¤ªà¥à¤°à¥à¤·à¤ƒ à¤¸à¥à¤µà¤®à¥ à¤•à¤°à¥à¤¤à¤¾à¤°à¤‚ à¤®à¤¨à¥à¤¯à¤¤à¥‡à¥¤</a:t>
             </a:r>
             <a:endParaRPr lang="en-US" sz="1050" dirty="0"/>
           </a:p>
@@ -4217,7 +4217,7 @@
                 <a:ea typeface="Tiro Devanagari Sanskrit" pitchFamily="34" charset="-122"/>
                 <a:cs typeface="Tiro Devanagari Sanskrit" pitchFamily="34" charset="-120"/>
               </a:rPr>
-              <a:t>धर्म</a:t>
+              <a:t>à¤§à¤°à¥à¤®</a:t>
             </a:r>
             <a:endParaRPr lang="en-US" sz="3000" dirty="0"/>
           </a:p>
@@ -4348,7 +4348,7 @@
                 <a:ea typeface="Tiro Devanagari Sanskrit" pitchFamily="34" charset="-122"/>
                 <a:cs typeface="Tiro Devanagari Sanskrit" pitchFamily="34" charset="-120"/>
               </a:rPr>
-              <a:t>स्वधर्मः</a:t>
+              <a:t>à¤¸à¥à¤µà¤§à¤°à¥à¤®à¤ƒ</a:t>
             </a:r>
             <a:endParaRPr lang="en-US" sz="1300" dirty="0"/>
           </a:p>
@@ -4387,7 +4387,7 @@
                 <a:ea typeface="Cormorant Garamond" pitchFamily="34" charset="-122"/>
                 <a:cs typeface="Cormorant Garamond" pitchFamily="34" charset="-120"/>
               </a:rPr>
-              <a:t>BG 3.35 · 18.47</a:t>
+              <a:t>BG 3.35 Â· 18.47</a:t>
             </a:r>
             <a:endParaRPr lang="en-US" sz="950" dirty="0"/>
           </a:p>
@@ -4429,7 +4429,7 @@
                 <a:ea typeface="Tiro Devanagari Sanskrit" pitchFamily="34" charset="-122"/>
                 <a:cs typeface="Tiro Devanagari Sanskrit" pitchFamily="34" charset="-120"/>
               </a:rPr>
-              <a:t>"श्रेयान् स्वधर्मो विगुणः परधर्मात् स्वनुष्ठितात्" — स्व-स्वभाव-जातं कर्म एव अनुष्ठेयम्।</a:t>
+              <a:t>"à¤¶à¥à¤°à¥‡à¤¯à¤¾à¤¨à¥ à¤¸à¥à¤µà¤§à¤°à¥à¤®à¥‹ à¤µà¤¿à¤—à¥à¤£à¤ƒ à¤ªà¤°à¤§à¤°à¥à¤®à¤¾à¤¤à¥ à¤¸à¥à¤µà¤¨à¥à¤·à¥à¤ à¤¿à¤¤à¤¾à¤¤à¥" â€” à¤¸à¥à¤µ-à¤¸à¥à¤µà¤­à¤¾à¤µ-à¤œà¤¾à¤¤à¤‚ à¤•à¤°à¥à¤® à¤à¤µ à¤…à¤¨à¥à¤·à¥à¤ à¥‡à¤¯à¤®à¥à¥¤</a:t>
             </a:r>
             <a:endParaRPr lang="en-US" sz="1050" dirty="0"/>
           </a:p>
@@ -4518,7 +4518,7 @@
                 <a:ea typeface="Tiro Devanagari Sanskrit" pitchFamily="34" charset="-122"/>
                 <a:cs typeface="Tiro Devanagari Sanskrit" pitchFamily="34" charset="-120"/>
               </a:rPr>
-              <a:t>वर्ण-स्वभावः</a:t>
+              <a:t>à¤µà¤°à¥à¤£-à¤¸à¥à¤µà¤­à¤¾à¤µà¤ƒ</a:t>
             </a:r>
             <a:endParaRPr lang="en-US" sz="1300" dirty="0"/>
           </a:p>
@@ -4557,7 +4557,7 @@
                 <a:ea typeface="Cormorant Garamond" pitchFamily="34" charset="-122"/>
                 <a:cs typeface="Cormorant Garamond" pitchFamily="34" charset="-120"/>
               </a:rPr>
-              <a:t>BG 4.13 · 18.41–44</a:t>
+              <a:t>BG 4.13 Â· 18.41â€“44</a:t>
             </a:r>
             <a:endParaRPr lang="en-US" sz="950" dirty="0"/>
           </a:p>
@@ -4599,7 +4599,7 @@
                 <a:ea typeface="Tiro Devanagari Sanskrit" pitchFamily="34" charset="-122"/>
                 <a:cs typeface="Tiro Devanagari Sanskrit" pitchFamily="34" charset="-120"/>
               </a:rPr>
-              <a:t>ब्राह्मण-क्षत्रिय-वैश्य-शूद्राः — गुण-कर्म-विभागेन उद्भूताः कर्तव्याः। माध्वमते एते जीवानां नित्य-स्वरूप-योग्यतायां निहिताः।</a:t>
+              <a:t>à¤¬à¥à¤°à¤¾à¤¹à¥à¤®à¤£-à¤•à¥à¤·à¤¤à¥à¤°à¤¿à¤¯-à¤µà¥ˆà¤¶à¥à¤¯-à¤¶à¥‚à¤¦à¥à¤°à¤¾à¤ƒ â€” à¤—à¥à¤£-à¤•à¤°à¥à¤®-à¤µà¤¿à¤­à¤¾à¤—à¥‡à¤¨ à¤‰à¤¦à¥à¤­à¥‚à¤¤à¤¾à¤ƒ à¤•à¤°à¥à¤¤à¤µà¥à¤¯à¤¾à¤ƒà¥¤ à¤®à¤¾à¤§à¥à¤µà¤®à¤¤à¥‡ à¤à¤¤à¥‡ à¤œà¥€à¤µà¤¾à¤¨à¤¾à¤‚ à¤¨à¤¿à¤…</a:t>
             </a:r>
             <a:endParaRPr lang="en-US" sz="1050" dirty="0"/>
           </a:p>
@@ -4688,7 +4688,7 @@
                 <a:ea typeface="Tiro Devanagari Sanskrit" pitchFamily="34" charset="-122"/>
                 <a:cs typeface="Tiro Devanagari Sanskrit" pitchFamily="34" charset="-120"/>
               </a:rPr>
-              <a:t>निष्कामकर्म</a:t>
+              <a:t>à¤¨à¤¿à¤·à¥à¤•à¤¾à¤®à¤•à¤°à¥à¤®</a:t>
             </a:r>
             <a:endParaRPr lang="en-US" sz="1300" dirty="0"/>
           </a:p>
@@ -4727,7 +4727,7 @@
                 <a:ea typeface="Cormorant Garamond" pitchFamily="34" charset="-122"/>
                 <a:cs typeface="Cormorant Garamond" pitchFamily="34" charset="-120"/>
               </a:rPr>
-              <a:t>BG 2.47 · 4.20</a:t>
+              <a:t>BG 2.47 Â· 4.20</a:t>
             </a:r>
             <a:endParaRPr lang="en-US" sz="950" dirty="0"/>
           </a:p>
@@ -4769,7 +4769,7 @@
                 <a:ea typeface="Tiro Devanagari Sanskrit" pitchFamily="34" charset="-122"/>
                 <a:cs typeface="Tiro Devanagari Sanskrit" pitchFamily="34" charset="-120"/>
               </a:rPr>
-              <a:t>फलाकाङ्क्षां विना अनुष्ठितं कर्म। गीतायाः मुख्यः नैतिकः आदेशः।</a:t>
+              <a:t>à¤«à¤²à¤¾à¤•à¤¾à¤™à¥à¤•à¥à¤·à¤¾à¤‚ à¤µà¤¿à¤¨à¤¾ à¤…à¤¨à¥à¤·à¥à¤ à¤¿à¤¤à¤‚ à¤•à¤°à¥à¤®à¥¤ à¤—à¥€à¤¤à¤¾à¤¯à¤¾à¤ƒ à¤®à¥à¤–à¥à¤¯à¤ƒ à¤¨à¥ˆà¤¤à¤¿à¤•à¤ƒ à¤†à¤¦à¥‡à¤¶à¤ƒà¥¤</a:t>
             </a:r>
             <a:endParaRPr lang="en-US" sz="1050" dirty="0"/>
           </a:p>
@@ -4858,7 +4858,7 @@
                 <a:ea typeface="Tiro Devanagari Sanskrit" pitchFamily="34" charset="-122"/>
                 <a:cs typeface="Tiro Devanagari Sanskrit" pitchFamily="34" charset="-120"/>
               </a:rPr>
-              <a:t>स्थितप्रज्ञः</a:t>
+              <a:t>à¤¸à¥à¤¥à¤¿à¤¤à¤ªà¥à¤°à¤œà¥à¤žà¤ƒ</a:t>
             </a:r>
             <a:endParaRPr lang="en-US" sz="1300" dirty="0"/>
           </a:p>
@@ -4897,7 +4897,7 @@
                 <a:ea typeface="Cormorant Garamond" pitchFamily="34" charset="-122"/>
                 <a:cs typeface="Cormorant Garamond" pitchFamily="34" charset="-120"/>
               </a:rPr>
-              <a:t>BG 2.55–72</a:t>
+              <a:t>BG 2.55â€“72</a:t>
             </a:r>
             <a:endParaRPr lang="en-US" sz="950" dirty="0"/>
           </a:p>
@@ -4939,7 +4939,7 @@
                 <a:ea typeface="Tiro Devanagari Sanskrit" pitchFamily="34" charset="-122"/>
                 <a:cs typeface="Tiro Devanagari Sanskrit" pitchFamily="34" charset="-120"/>
               </a:rPr>
-              <a:t>सुख-दुःखयोः समः, सङ्ग-भय-क्रोध-विमुक्तः, सर्वतः सङ्कुचित-इन्द्रियः। द्वितीयाध्यायस्य अन्तिमं चित्रणम्।</a:t>
+              <a:t>à¤¸à¥à¤–-à¤¦à¥à¤ƒà¤–à¤¯à¥‹à¤ƒ à¤¸à¤®à¤ƒ, à¤¸à¤™à¥à¤—-à¤­à¤¯-à¤•à¥à¤°à¥‹à¤§-à¤µà¤¿à¤®à¥à¤•à¥à¤¤à¤ƒ, à¤¸à¤°à¥à¤µà¤¤à¤ƒ à¤¸à¤™à¥à¤•à¥à¤šà¤¿à¤¤-à¤‡à¤¨à¥à¤¦à¥à¤°à¤¿à¤¯à¤ƒà¥¤ à¤¦à¥à¤µà¤¿à¤¤à¥€à¤¯à¤¾à¤§à¥à¤¯à¤¾à¤¯à¤¸à¥à¤¯ à¤…à¤¨à¥à¤¤à¤¿à¤®à¤‚ à¤šà¤¿à…</a:t>
             </a:r>
             <a:endParaRPr lang="en-US" sz="1050" dirty="0"/>
           </a:p>
@@ -5049,7 +5049,7 @@
                 <a:ea typeface="Tiro Devanagari Sanskrit" pitchFamily="34" charset="-122"/>
                 <a:cs typeface="Tiro Devanagari Sanskrit" pitchFamily="34" charset="-120"/>
               </a:rPr>
-              <a:t>दोष</a:t>
+              <a:t>à¤¦à¥‹à¤·</a:t>
             </a:r>
             <a:endParaRPr lang="en-US" sz="3000" dirty="0"/>
           </a:p>
@@ -5180,7 +5180,7 @@
                 <a:ea typeface="Tiro Devanagari Sanskrit" pitchFamily="34" charset="-122"/>
                 <a:cs typeface="Tiro Devanagari Sanskrit" pitchFamily="34" charset="-120"/>
               </a:rPr>
-              <a:t>आसुरी सम्पत्</a:t>
+              <a:t>à¤†à¤¸à¥à¤°à¥€ à¤¸à¤®à¥à¤ªà¤¤à¥</a:t>
             </a:r>
             <a:endParaRPr lang="en-US" sz="1300" dirty="0"/>
           </a:p>
@@ -5219,7 +5219,7 @@
                 <a:ea typeface="Cormorant Garamond" pitchFamily="34" charset="-122"/>
                 <a:cs typeface="Cormorant Garamond" pitchFamily="34" charset="-120"/>
               </a:rPr>
-              <a:t>BG 16.4 · 16.7–20</a:t>
+              <a:t>BG 16.4 Â· 16.7â€“20</a:t>
             </a:r>
             <a:endParaRPr lang="en-US" sz="950" dirty="0"/>
           </a:p>
@@ -5261,7 +5261,7 @@
                 <a:ea typeface="Tiro Devanagari Sanskrit" pitchFamily="34" charset="-122"/>
                 <a:cs typeface="Tiro Devanagari Sanskrit" pitchFamily="34" charset="-120"/>
               </a:rPr>
-              <a:t>दम्भः दर्पः अभिमानः क्रोधः पारुष्यम् अज्ञानम् — दैवी-सम्पदः विपरीतम्। बन्धाय कल्पते।</a:t>
+              <a:t>à¤¦à¤®à¥à¤­à¤ƒ à¤¦à¤°à¥à¤ªà¤ƒ à¤…à¤­à¤¿à¤®à¤¾à¤¨à¤ƒ à¤•à¥à¤°à¥‹à¤§à¤ƒ à¤ªà¤¾à¤°à¥à¤·à¥à¤¯à¤®à¥ à¤…à¤œà¥à¤žà¤¾à¤¨à¤®à¥ â€” à¤¦à¥ˆà¤µà¥€-à¤¸à¤®à¥à¤ªà¤¦à¤ƒ à¤µà¤¿à¤ªà¤°à¥€à¤¤à¤®à¥à¥¤ à¤¬à¤¨à¥à¤§à¤¾à¤¯ à¤•à¤²à¥à¤ªà¤¤à¥‡à¥¤</a:t>
             </a:r>
             <a:endParaRPr lang="en-US" sz="1050" dirty="0"/>
           </a:p>
@@ -5350,7 +5350,7 @@
                 <a:ea typeface="Tiro Devanagari Sanskrit" pitchFamily="34" charset="-122"/>
                 <a:cs typeface="Tiro Devanagari Sanskrit" pitchFamily="34" charset="-120"/>
               </a:rPr>
-              <a:t>कामः</a:t>
+              <a:t>à¤•à¤¾à¤®à¤ƒ</a:t>
             </a:r>
             <a:endParaRPr lang="en-US" sz="1300" dirty="0"/>
           </a:p>
@@ -5389,7 +5389,7 @@
                 <a:ea typeface="Cormorant Garamond" pitchFamily="34" charset="-122"/>
                 <a:cs typeface="Cormorant Garamond" pitchFamily="34" charset="-120"/>
               </a:rPr>
-              <a:t>BG 3.37–39</a:t>
+              <a:t>BG 3.37â€“39</a:t>
             </a:r>
             <a:endParaRPr lang="en-US" sz="950" dirty="0"/>
           </a:p>
@@ -5431,7 +5431,7 @@
                 <a:ea typeface="Tiro Devanagari Sanskrit" pitchFamily="34" charset="-122"/>
                 <a:cs typeface="Tiro Devanagari Sanskrit" pitchFamily="34" charset="-120"/>
               </a:rPr>
-              <a:t>"रजोगुण-समुद्भवः, महाशनः, महापाप्मा, इह वैरी" — कृष्णः कामं प्रथमं शत्रुं नाम्ना निर्दिशति।</a:t>
+              <a:t>"à¤°à¤œà¥‹à¤—à¥à¤£-à¤¸à¤®à¥à¤¦à¥à¤­à¤µà¤ƒ, à¤®à¤¹à¤¾à¤¶à¤¨à¤ƒ, à¤®à¤¹à¤¾à¤ªà¤¾à¤ªà¥à¤®à¤¾, à¤‡à¤¹ à¤µà¥ˆà¤°à¥€" â€” à¤•à¥ƒà¤·à¥à¤£à¤ƒ à¤•à¤¾à¤®à¤‚ à¤ªà¥à¤°à¤¥à¤®à¤‚ à¤¶à¤¤à¥à¤°à¥à¤‚ à¤¨à¤¾à¤®à¥à¤¨à¤¾ à¤¨à¤¿à¤°à¥à¤¦à¤¿à¤¶à¤¤à¤¿à¥¤</a:t>
             </a:r>
             <a:endParaRPr lang="en-US" sz="1050" dirty="0"/>
           </a:p>
@@ -5520,7 +5520,7 @@
                 <a:ea typeface="Tiro Devanagari Sanskrit" pitchFamily="34" charset="-122"/>
                 <a:cs typeface="Tiro Devanagari Sanskrit" pitchFamily="34" charset="-120"/>
               </a:rPr>
-              <a:t>क्रोधः</a:t>
+              <a:t>à¤•à¥à¤°à¥‹à¤§à¤ƒ</a:t>
             </a:r>
             <a:endParaRPr lang="en-US" sz="1300" dirty="0"/>
           </a:p>
@@ -5559,7 +5559,7 @@
                 <a:ea typeface="Cormorant Garamond" pitchFamily="34" charset="-122"/>
                 <a:cs typeface="Cormorant Garamond" pitchFamily="34" charset="-120"/>
               </a:rPr>
-              <a:t>BG 2.62–63 · 3.37</a:t>
+              <a:t>BG 2.62â€“63 Â· 3.37</a:t>
             </a:r>
             <a:endParaRPr lang="en-US" sz="950" dirty="0"/>
           </a:p>
@@ -5601,7 +5601,7 @@
                 <a:ea typeface="Tiro Devanagari Sanskrit" pitchFamily="34" charset="-122"/>
                 <a:cs typeface="Tiro Devanagari Sanskrit" pitchFamily="34" charset="-120"/>
               </a:rPr>
-              <a:t>काम-विघातात् क्रोधः उद्भवति; क्रोधात् सम्मोहः; सम्मोहात् स्मृति-विभ्रमः।</a:t>
+              <a:t>à¤•à¤¾à¤®-à¤µà¤¿à¤˜à¤¾à¤¤à¤¾à¤¤à¥ à¤•à¥à¤°à¥‹à¤§à¤ƒ à¤‰à¤¦à¥à¤­à¤µà¤¤à¤¿; à¤•à¥à¤°à¥‹à¤§à¤¾à¤¤à¥ à¤¸à¤®à¥à¤®à¥‹à¤¹à¤ƒ; à¤¸à¤®à¥à¤®à¥‹à¤¹à¤¾à¤¤à¥ à¤¸à¥à¤®à¥ƒà¤¤à¤¿-à¤µà¤¿à¤­à¥à¤°à¤®à¤ƒà¥¤</a:t>
             </a:r>
             <a:endParaRPr lang="en-US" sz="1050" dirty="0"/>
           </a:p>
@@ -5690,7 +5690,7 @@
                 <a:ea typeface="Tiro Devanagari Sanskrit" pitchFamily="34" charset="-122"/>
                 <a:cs typeface="Tiro Devanagari Sanskrit" pitchFamily="34" charset="-120"/>
               </a:rPr>
-              <a:t>लोभः</a:t>
+              <a:t>à¤²à¥‹à¤­à¤ƒ</a:t>
             </a:r>
             <a:endParaRPr lang="en-US" sz="1300" dirty="0"/>
           </a:p>
@@ -5771,7 +5771,7 @@
                 <a:ea typeface="Tiro Devanagari Sanskrit" pitchFamily="34" charset="-122"/>
                 <a:cs typeface="Tiro Devanagari Sanskrit" pitchFamily="34" charset="-120"/>
               </a:rPr>
-              <a:t>काम-क्रोधाभ्यां सह नरकस्य त्रिविधं द्वारम्। मार्गारम्भे एव त्यजनीयः।</a:t>
+              <a:t>à¤•à¤¾à¤®-à¤•à¥à¤°à¥‹à¤§à¤¾à¤­à¥à¤¯à¤¾à¤‚ à¤¸à¤¹ à¤¨à¤°à¤•à¤¸à¥à¤¯ à¤¤à¥à¤°à¤¿à¤µà¤¿à¤§à¤‚ à¤¦à¥à¤µà¤¾à¤°à¤®à¥à¥¤ à¤®à¤¾à¤°à¥à¤—à¤¾à¤°à¤®à¥à¤­à¥‡ à¤à¤µ à¤¤à¥à¤¯à¤œà¤¨à¥€à¤¯à¤ƒà¥¤</a:t>
             </a:r>
             <a:endParaRPr lang="en-US" sz="1050" dirty="0"/>
           </a:p>
@@ -5881,7 +5881,7 @@
                 <a:ea typeface="Tiro Devanagari Sanskrit" pitchFamily="34" charset="-122"/>
                 <a:cs typeface="Tiro Devanagari Sanskrit" pitchFamily="34" charset="-120"/>
               </a:rPr>
-              <a:t>फल</a:t>
+              <a:t>à¤«à¤²</a:t>
             </a:r>
             <a:endParaRPr lang="en-US" sz="3000" dirty="0"/>
           </a:p>
@@ -6012,7 +6012,7 @@
                 <a:ea typeface="Tiro Devanagari Sanskrit" pitchFamily="34" charset="-122"/>
                 <a:cs typeface="Tiro Devanagari Sanskrit" pitchFamily="34" charset="-120"/>
               </a:rPr>
-              <a:t>मोक्षः</a:t>
+              <a:t>à¤®à¥‹à¤•à¥à¤·à¤ƒ</a:t>
             </a:r>
             <a:endParaRPr lang="en-US" sz="1300" dirty="0"/>
           </a:p>
@@ -6051,7 +6051,7 @@
                 <a:ea typeface="Cormorant Garamond" pitchFamily="34" charset="-122"/>
                 <a:cs typeface="Cormorant Garamond" pitchFamily="34" charset="-120"/>
               </a:rPr>
-              <a:t>BG 5.24–26 · 18.66</a:t>
+              <a:t>BG 5.24â€“26 Â· 18.66</a:t>
             </a:r>
             <a:endParaRPr lang="en-US" sz="950" dirty="0"/>
           </a:p>
@@ -6093,7 +6093,7 @@
                 <a:ea typeface="Tiro Devanagari Sanskrit" pitchFamily="34" charset="-122"/>
                 <a:cs typeface="Tiro Devanagari Sanskrit" pitchFamily="34" charset="-120"/>
               </a:rPr>
-              <a:t>संसारात् विनिर्मुक्तिः हरेः नित्यसन्निधिप्राप्तिश्च। माध्वमते मोक्षस्य चतुर्विधं तारतम्यम् — सालोक्य-सार्ष्टि-सामीप्य-सारूप्य-सायुज्यभेदेन।</a:t>
+              <a:t>à¤¸à¤‚à¤¸à¤¾à¤°à¤¾à¤¤à¥ à¤µà¤¿à¤¨à¤¿à¤°à¥à¤®à¥à¤•à¥à¤¤à¤¿à¤ƒ à¤¹à¤°à¥‡à¤ƒ à¤¨à¤¿à¤¤à¥à¤¯à¤¸à¤¨à¥à¤¨à¤¿à¤§à¤¿à¤ªà¥à¤°à¤¾à¤ªà¥à¤¤à¤¿à¤¶à¥à¤šà¥¤ à¤®à¤¾à¤§à¥à¤µà¤®à¤¤à¥‡ à¤®à¥‹à¤•à¥à¤·à¤¸à¥à¤¯ à¤šà¤¤à¥à¤°à¥à¤µà¤¿à¤§à¤‚ à¤¤à¤¾à¤°à¤¤à¤®à¥à¤¯à¤®à¥ â…</a:t>
             </a:r>
             <a:endParaRPr lang="en-US" sz="1050" dirty="0"/>
           </a:p>
@@ -6182,7 +6182,7 @@
                 <a:ea typeface="Tiro Devanagari Sanskrit" pitchFamily="34" charset="-122"/>
                 <a:cs typeface="Tiro Devanagari Sanskrit" pitchFamily="34" charset="-120"/>
               </a:rPr>
-              <a:t>चरमश्लोकफलम्</a:t>
+              <a:t>à¤šà¤°à¤®à¤¶à¥à¤²à¥‹à¤•à¤«à¤²à¤®à¥</a:t>
             </a:r>
             <a:endParaRPr lang="en-US" sz="1300" dirty="0"/>
           </a:p>
@@ -6263,7 +6263,7 @@
                 <a:ea typeface="Tiro Devanagari Sanskrit" pitchFamily="34" charset="-122"/>
                 <a:cs typeface="Tiro Devanagari Sanskrit" pitchFamily="34" charset="-120"/>
               </a:rPr>
-              <a:t>"अहं त्वा सर्वपापेभ्यो मोक्षयिष्यामि मा शुचः" — अष्टादशाध्याये कृष्णस्य प्रत्यक्षाश्वासः। माध्वसम्प्रदाये अयं गीताशास्त्रस्य शिरोभूतः श्लोकः।</a:t>
+              <a:t>"à¤…à¤¹à¤‚ à¤¤à¥à¤µà¤¾ à¤¸à¤°à¥à¤µà¤ªà¤¾à¤ªà¥‡à¤­à¥à¤¯à¥‹ à¤®à¥‹à¤•à¥à¤·à¤¯à¤¿à¤·à¥à¤¯à¤¾à¤®à¤¿ à¤®à¤¾ à¤¶à¥à¤šà¤ƒ" â€” à¤…à¤·à¥à¤Ÿà¤¾à¤¦à¤¶à¤¾à¤§à¥à¤¯à¤¾à¤¯à¥‡ à¤•à¥ƒà¤·à¥à¤£à¤¸à¥à¤¯ à¤ªà¥à¤°à¤¤à¥à¤¯à¤•à¥à¤·à¤¾à¤¶à¥à¤µà¤¾à¤¸à¤ƒà¥¤ à¤®à¤¾à¤§à¥…</a:t>
             </a:r>
             <a:endParaRPr lang="en-US" sz="1050" dirty="0"/>
           </a:p>
@@ -6352,7 +6352,7 @@
                 <a:ea typeface="Tiro Devanagari Sanskrit" pitchFamily="34" charset="-122"/>
                 <a:cs typeface="Tiro Devanagari Sanskrit" pitchFamily="34" charset="-120"/>
               </a:rPr>
-              <a:t>सालोक्यम्</a:t>
+              <a:t>à¤¸à¤¾à¤²à¥‹à¤•à¥à¤¯à¤®à¥</a:t>
             </a:r>
             <a:endParaRPr lang="en-US" sz="1300" dirty="0"/>
           </a:p>
@@ -6391,7 +6391,7 @@
                 <a:ea typeface="Cormorant Garamond" pitchFamily="34" charset="-122"/>
                 <a:cs typeface="Cormorant Garamond" pitchFamily="34" charset="-120"/>
               </a:rPr>
-              <a:t>BG 8.21 · 15.6</a:t>
+              <a:t>BG 8.21 Â· 15.6</a:t>
             </a:r>
             <a:endParaRPr lang="en-US" sz="950" dirty="0"/>
           </a:p>
@@ -6433,7 +6433,7 @@
                 <a:ea typeface="Tiro Devanagari Sanskrit" pitchFamily="34" charset="-122"/>
                 <a:cs typeface="Tiro Devanagari Sanskrit" pitchFamily="34" charset="-120"/>
               </a:rPr>
-              <a:t>मोक्षस्य प्रथमं तारतम्यम् — हरेः वैकुण्ठलोके निवासः, परं न तत्सान्निध्यम्।</a:t>
+              <a:t>à¤®à¥‹à¤•à¥à¤·à¤¸à¥à¤¯ à¤ªà¥à¤°à¤¥à¤®à¤‚ à¤¤à¤¾à¤°à¤¤à¤®à¥à¤¯à¤®à¥ â€” à¤¹à¤°à¥‡à¤ƒ à¤µà¥ˆà¤•à¥à¤£à¥à¤ à¤²à¥‹à¤•à¥‡ à¤¨à¤¿à¤µà¤¾à¤¸à¤ƒ, à¤ªà¤°à¤‚ à¤¨ à¤¤à¤¤à¥à¤¸à¤¾à¤¨à¥à¤¨à¤¿à¤§à¥à¤¯à¤®à¥à¥¤</a:t>
             </a:r>
             <a:endParaRPr lang="en-US" sz="1050" dirty="0"/>
           </a:p>
@@ -6522,7 +6522,7 @@
                 <a:ea typeface="Tiro Devanagari Sanskrit" pitchFamily="34" charset="-122"/>
                 <a:cs typeface="Tiro Devanagari Sanskrit" pitchFamily="34" charset="-120"/>
               </a:rPr>
-              <a:t>सामीप्यम्</a:t>
+              <a:t>à¤¸à¤¾à¤®à¥€à¤ªà¥à¤¯à¤®à¥</a:t>
             </a:r>
             <a:endParaRPr lang="en-US" sz="1300" dirty="0"/>
           </a:p>
@@ -6603,7 +6603,7 @@
                 <a:ea typeface="Tiro Devanagari Sanskrit" pitchFamily="34" charset="-122"/>
                 <a:cs typeface="Tiro Devanagari Sanskrit" pitchFamily="34" charset="-120"/>
               </a:rPr>
-              <a:t>द्वितीयं तारतम्यम् — हरेः स्वधाम्नि तत्सान्निध्यप्राप्तिः। सालोक्यादुत्तरं सारूप्यात् न्यूनम्।</a:t>
+              <a:t>à¤¦à¥à¤µà¤¿à¤¤à¥€à¤¯à¤‚ à¤¤à¤¾à¤°à¤¤à¤®à¥à¤¯à¤®à¥ â€” à¤¹à¤°à¥‡à¤ƒ à¤¸à¥à¤µà¤§à¤¾à¤®à¥à¤¨à¤¿ à¤¤à¤¤à¥à¤¸à¤¾à¤¨à¥à¤¨à¤¿à¤§à¥à¤¯à¤ªà¥à¤°à¤¾à¤ªà¥à¤¤à¤¿à¤ƒà¥¤ à¤¸à¤¾à¤²à¥‹à¤•à¥à¤¯à¤¾à¤¦à¥à¤¤à¥à¤¤à¤°à¤‚ à¤¸à¤¾à¤°à¥‚à¤ªà¥à¤¯à¤¾à¤¤à¥ à¤¨à¥à¤¯à¥‚à¤¨à…</a:t>
             </a:r>
             <a:endParaRPr lang="en-US" sz="1050" dirty="0"/>
           </a:p>
@@ -6713,7 +6713,7 @@
                 <a:ea typeface="Tiro Devanagari Sanskrit" pitchFamily="34" charset="-122"/>
                 <a:cs typeface="Tiro Devanagari Sanskrit" pitchFamily="34" charset="-120"/>
               </a:rPr>
-              <a:t>यज्ञ</a:t>
+              <a:t>à¤¯à¤œà¥à¤ž</a:t>
             </a:r>
             <a:endParaRPr lang="en-US" sz="3000" dirty="0"/>
           </a:p>
@@ -6844,7 +6844,7 @@
                 <a:ea typeface="Tiro Devanagari Sanskrit" pitchFamily="34" charset="-122"/>
                 <a:cs typeface="Tiro Devanagari Sanskrit" pitchFamily="34" charset="-120"/>
               </a:rPr>
-              <a:t>द्रव्ययज्ञः</a:t>
+              <a:t>à¤¦à¥à¤°à¤µà¥à¤¯à¤¯à¤œà¥à¤žà¤ƒ</a:t>
             </a:r>
             <a:endParaRPr lang="en-US" sz="1300" dirty="0"/>
           </a:p>
@@ -6925,7 +6925,7 @@
                 <a:ea typeface="Tiro Devanagari Sanskrit" pitchFamily="34" charset="-122"/>
                 <a:cs typeface="Tiro Devanagari Sanskrit" pitchFamily="34" charset="-120"/>
               </a:rPr>
-              <a:t>धन-वस्त्व-अन्नादिद्रव्यार्पणरूपः यज्ञः — चतुर्थाध्यायाष्टाविंशे श्लोके कृष्णोक्तयज्ञानां प्रथमः।</a:t>
+              <a:t>à¤§à¤¨-à¤µà¤¸à¥à¤¤à¥à¤µ-à¤…à¤¨à¥à¤¨à¤¾à¤¦à¤¿à¤¦à¥à¤°à¤µà¥à¤¯à¤¾à¤°à¥à¤ªà¤£à¤°à¥‚à¤ªà¤ƒ à¤¯à¤œà¥à¤žà¤ƒ â€” à¤šà¤¤à¥à¤°à¥à¤¥à¤¾à¤§à¥à¤¯à¤¾à¤¯à¤¾à¤·à¥à¤Ÿà¤¾à¤µà¤¿à¤‚à¤¶à¥‡ à¤¶à¥à¤²à¥‹à¤•à¥‡ à¤•à¥ƒà¤·à¥à¤£à¥‹à¤•à¥à¤¤à¤¯à¤œà¥à¤žà¤¾à¤¨à¤¾à¤‚ à¤ªà¥à…</a:t>
             </a:r>
             <a:endParaRPr lang="en-US" sz="1050" dirty="0"/>
           </a:p>
@@ -7014,7 +7014,7 @@
                 <a:ea typeface="Tiro Devanagari Sanskrit" pitchFamily="34" charset="-122"/>
                 <a:cs typeface="Tiro Devanagari Sanskrit" pitchFamily="34" charset="-120"/>
               </a:rPr>
-              <a:t>तपोयज्ञः</a:t>
+              <a:t>à¤¤à¤ªà¥‹à¤¯à¤œà¥à¤žà¤ƒ</a:t>
             </a:r>
             <a:endParaRPr lang="en-US" sz="1300" dirty="0"/>
           </a:p>
@@ -7095,7 +7095,7 @@
                 <a:ea typeface="Tiro Devanagari Sanskrit" pitchFamily="34" charset="-122"/>
                 <a:cs typeface="Tiro Devanagari Sanskrit" pitchFamily="34" charset="-120"/>
               </a:rPr>
-              <a:t>कायिक-वाचिक-मानसतपसां हरयेऽर्पणरूपः यज्ञः।</a:t>
+              <a:t>à¤•à¤¾à¤¯à¤¿à¤•-à¤µà¤¾à¤šà¤¿à¤•-à¤®à¤¾à¤¨à¤¸à¤¤à¤ªà¤¸à¤¾à¤‚ à¤¹à¤°à¤¯à¥‡à¤½à¤°à¥à¤ªà¤£à¤°à¥‚à¤ªà¤ƒ à¤¯à¤œà¥à¤žà¤ƒà¥¤</a:t>
             </a:r>
             <a:endParaRPr lang="en-US" sz="1050" dirty="0"/>
           </a:p>
@@ -7184,7 +7184,7 @@
                 <a:ea typeface="Tiro Devanagari Sanskrit" pitchFamily="34" charset="-122"/>
                 <a:cs typeface="Tiro Devanagari Sanskrit" pitchFamily="34" charset="-120"/>
               </a:rPr>
-              <a:t>योगयज्ञः</a:t>
+              <a:t>à¤¯à¥‹à¤—à¤¯à¤œà¥à¤žà¤ƒ</a:t>
             </a:r>
             <a:endParaRPr lang="en-US" sz="1300" dirty="0"/>
           </a:p>
@@ -7223,7 +7223,7 @@
                 <a:ea typeface="Cormorant Garamond" pitchFamily="34" charset="-122"/>
                 <a:cs typeface="Cormorant Garamond" pitchFamily="34" charset="-120"/>
               </a:rPr>
-              <a:t>BG 4.28–30</a:t>
+              <a:t>BG 4.28â€“30</a:t>
             </a:r>
             <a:endParaRPr lang="en-US" sz="950" dirty="0"/>
           </a:p>
@@ -7265,7 +7265,7 @@
                 <a:ea typeface="Tiro Devanagari Sanskrit" pitchFamily="34" charset="-122"/>
                 <a:cs typeface="Tiro Devanagari Sanskrit" pitchFamily="34" charset="-120"/>
               </a:rPr>
-              <a:t>प्राणापानसंयम-अष्टाङ्गयोगादिरूपस्य योगानुष्ठानस्य हरये अर्पणम् — एष योगयज्ञः।</a:t>
+              <a:t>à¤ªà¥à¤°à¤¾à¤£à¤¾à¤ªà¤¾à¤¨à¤¸à¤‚à¤¯à¤®-à¤…à¤·à¥à¤Ÿà¤¾à¤™à¥à¤—à¤¯à¥‹à¤—à¤¾à¤¦à¤¿à¤°à¥‚à¤ªà¤¸à¥à¤¯ à¤¯à¥‹à¤—à¤¾à¤¨à¥à¤·à¥à¤ à¤¾à¤¨à¤¸à¥à¤¯ à¤¹à¤°à¤¯à¥‡ à¤…à¤°à¥à¤ªà¤£à¤®à¥ â€” à¤à¤· à¤¯à¥‹à¤—à¤¯à¤œà¥à¤žà¤ƒà¥¤</a:t>
             </a:r>
             <a:endParaRPr lang="en-US" sz="1050" dirty="0"/>
           </a:p>
@@ -7354,7 +7354,7 @@
                 <a:ea typeface="Tiro Devanagari Sanskrit" pitchFamily="34" charset="-122"/>
                 <a:cs typeface="Tiro Devanagari Sanskrit" pitchFamily="34" charset="-120"/>
               </a:rPr>
-              <a:t>स्वाध्यायज्ञानयज्ञः</a:t>
+              <a:t>à¤¸à¥à¤µà¤¾à¤§à¥à¤¯à¤¾à¤¯à¤œà¥à¤žà¤¾à¤¨à¤¯à¤œà¥à¤žà¤ƒ</a:t>
             </a:r>
             <a:endParaRPr lang="en-US" sz="1300" dirty="0"/>
           </a:p>
@@ -7435,7 +7435,7 @@
                 <a:ea typeface="Tiro Devanagari Sanskrit" pitchFamily="34" charset="-122"/>
                 <a:cs typeface="Tiro Devanagari Sanskrit" pitchFamily="34" charset="-120"/>
               </a:rPr>
-              <a:t>शास्त्रस्वाध्यायः तदुक्तार्थज्ञानसहितः — वाङ्मयेषु यज्ञेषु उत्तमः।</a:t>
+              <a:t>à¤¶à¤¾à¤¸à¥à¤¤à¥à¤°à¤¸à¥à¤µà¤¾à¤§à¥à¤¯à¤¾à¤¯à¤ƒ à¤¤à¤¦à¥à¤•à¥à¤¤à¤¾à¤°à¥à¤¥à¤œà¥à¤žà¤¾à¤¨à¤¸à¤¹à¤¿à¤¤à¤ƒ â€” à¤µà¤¾à¤™à¥à¤®à¤¯à¥‡à¤·à¥ à¤¯à¤œà¥à¤žà¥‡à¤·à¥ à¤‰à¤¤à¥à¤¤à¤®à¤ƒà¥¤</a:t>
             </a:r>
             <a:endParaRPr lang="en-US" sz="1050" dirty="0"/>
           </a:p>
@@ -7545,7 +7545,7 @@
                 <a:ea typeface="Tiro Devanagari Sanskrit" pitchFamily="34" charset="-122"/>
                 <a:cs typeface="Tiro Devanagari Sanskrit" pitchFamily="34" charset="-120"/>
               </a:rPr>
-              <a:t>प्रतीक</a:t>
+              <a:t>à¤ªà¥à¤°à¤¤à¥€à¤•</a:t>
             </a:r>
             <a:endParaRPr lang="en-US" sz="3000" dirty="0"/>
           </a:p>
@@ -7676,7 +7676,7 @@
                 <a:ea typeface="Tiro Devanagari Sanskrit" pitchFamily="34" charset="-122"/>
                 <a:cs typeface="Tiro Devanagari Sanskrit" pitchFamily="34" charset="-120"/>
               </a:rPr>
-              <a:t>अश्वत्थवृक्षः</a:t>
+              <a:t>à¤…à¤¶à¥à¤µà¤¤à¥à¤¥à¤µà¥ƒà¤•à¥à¤·à¤ƒ</a:t>
             </a:r>
             <a:endParaRPr lang="en-US" sz="1300" dirty="0"/>
           </a:p>
@@ -7715,7 +7715,7 @@
                 <a:ea typeface="Cormorant Garamond" pitchFamily="34" charset="-122"/>
                 <a:cs typeface="Cormorant Garamond" pitchFamily="34" charset="-120"/>
               </a:rPr>
-              <a:t>BG 15.1–3</a:t>
+              <a:t>BG 15.1â€“3</a:t>
             </a:r>
             <a:endParaRPr lang="en-US" sz="950" dirty="0"/>
           </a:p>
@@ -7757,7 +7757,7 @@
                 <a:ea typeface="Tiro Devanagari Sanskrit" pitchFamily="34" charset="-122"/>
                 <a:cs typeface="Tiro Devanagari Sanskrit" pitchFamily="34" charset="-120"/>
               </a:rPr>
-              <a:t>ऊर्ध्वमूलः (हरिः) अधःशाखः (लोकाः) संसारवृक्षः — गुणैः सिक्तः, विषयाङ्कुरोपेतः, असङ्गशस्त्रेण छेद्यः।</a:t>
+              <a:t>à¤Šà¤°à¥à¤§à¥à¤µà¤®à¥‚à¤²à¤ƒ (à¤¹à¤°à¤¿à¤ƒ) à¤…à¤§à¤ƒà¤¶à¤¾à¤–à¤ƒ (à¤²à¥‹à¤•à¤¾à¤ƒ) à¤¸à¤‚à¤¸à¤¾à¤°à¤µà¥ƒà¤•à¥à¤·à¤ƒ â€” à¤—à¥à¤£à¥ˆà¤ƒ à¤¸à¤¿à¤•à¥à¤¤à¤ƒ, à¤µà¤¿à¤·à¤¯à¤¾à¤™à¥à¤•à¥à¤°à¥‹à¤ªà¥‡à¤¤à¤ƒ, à¤…à¤¸à¤™à¥à¤—à¤¶à¤¸à¥à¤¤à¥à¤°à¥‡à¤£ à¤›à¥‡à¤¦à¥…</a:t>
             </a:r>
             <a:endParaRPr lang="en-US" sz="1050" dirty="0"/>
           </a:p>
@@ -7846,7 +7846,7 @@
                 <a:ea typeface="Tiro Devanagari Sanskrit" pitchFamily="34" charset="-122"/>
                 <a:cs typeface="Tiro Devanagari Sanskrit" pitchFamily="34" charset="-120"/>
               </a:rPr>
-              <a:t>रथरूपकम्</a:t>
+              <a:t>à¤°à¤¥à¤°à¥‚à¤ªà¤•à¤®à¥</a:t>
             </a:r>
             <a:endParaRPr lang="en-US" sz="1300" dirty="0"/>
           </a:p>
@@ -7885,7 +7885,7 @@
                 <a:ea typeface="Cormorant Garamond" pitchFamily="34" charset="-122"/>
                 <a:cs typeface="Cormorant Garamond" pitchFamily="34" charset="-120"/>
               </a:rPr>
-              <a:t>BG 1.21–25 · 18.78</a:t>
+              <a:t>BG 1.21â€“25 Â· 18.78</a:t>
             </a:r>
             <a:endParaRPr lang="en-US" sz="950" dirty="0"/>
           </a:p>
@@ -7927,7 +7927,7 @@
                 <a:ea typeface="Tiro Devanagari Sanskrit" pitchFamily="34" charset="-122"/>
                 <a:cs typeface="Tiro Devanagari Sanskrit" pitchFamily="34" charset="-120"/>
               </a:rPr>
-              <a:t>प्रथमद्वितीयाध्याययोः सूचितम् — कृष्णः सारथिः, अर्जुनो रथी। कठोपनिषदुक्तरथरूपकस्य प्रतिध्वनिः।</a:t>
+              <a:t>à¤ªà¥à¤°à¤¥à¤®à¤¦à¥à¤µà¤¿à¤¤à¥€à¤¯à¤¾à¤§à¥à¤¯à¤¾à¤¯à¤¯à¥‹à¤ƒ à¤¸à¥‚à¤šà¤¿à¤¤à¤®à¥ â€” à¤•à¥ƒà¤·à¥à¤£à¤ƒ à¤¸à¤¾à¤°à¤¥à¤¿à¤ƒ, à¤…à¤°à¥à¤œà¥à¤¨à¥‹ à¤°à¤¥à¥€à¥¤ à¤•à¤ à¥‹à¤ªà¤¨à¤¿à¤·à¤¦à¥à¤•à¥à¤¤à¤°à¤¥à¤°à¥‚à¤ªà¤•à¤¸à¥à¤¯ à¤ªà¥à¤°à¤¤à¤¿à¤§à¥à¤µà¤¨à¤¿…</a:t>
             </a:r>
             <a:endParaRPr lang="en-US" sz="1050" dirty="0"/>
           </a:p>
@@ -8016,7 +8016,7 @@
                 <a:ea typeface="Tiro Devanagari Sanskrit" pitchFamily="34" charset="-122"/>
                 <a:cs typeface="Tiro Devanagari Sanskrit" pitchFamily="34" charset="-120"/>
               </a:rPr>
-              <a:t>प्रणवः (ॐ)</a:t>
+              <a:t>à¤ªà¥à¤°à¤£à¤µà¤ƒ (à¥)</a:t>
             </a:r>
             <a:endParaRPr lang="en-US" sz="1300" dirty="0"/>
           </a:p>
@@ -8055,7 +8055,7 @@
                 <a:ea typeface="Cormorant Garamond" pitchFamily="34" charset="-122"/>
                 <a:cs typeface="Cormorant Garamond" pitchFamily="34" charset="-120"/>
               </a:rPr>
-              <a:t>BG 8.13 · 17.23</a:t>
+              <a:t>BG 8.13 Â· 17.23</a:t>
             </a:r>
             <a:endParaRPr lang="en-US" sz="950" dirty="0"/>
           </a:p>
@@ -8097,7 +8097,7 @@
                 <a:ea typeface="Tiro Devanagari Sanskrit" pitchFamily="34" charset="-122"/>
                 <a:cs typeface="Tiro Devanagari Sanskrit" pitchFamily="34" charset="-120"/>
               </a:rPr>
-              <a:t>"ॐ इत्येकाक्षरं ब्रह्म" — अन्तकाले ॐकारमुच्चारयन् हरिमनुस्मरन् परमां गतिं प्राप्नोति।</a:t>
+              <a:t>"à¥ à¤‡à¤¤à¥à¤¯à¥‡à¤•à¤¾à¤•à¥à¤·à¤°à¤‚ à¤¬à¥à¤°à¤¹à¥à¤®" â€” à¤…à¤¨à¥à¤¤à¤•à¤¾à¤²à¥‡ à¥à¤•à¤¾à¤°à¤®à¥à¤šà¥à¤šà¤¾à¤°à¤¯à¤¨à¥ à¤¹à¤°à¤¿à¤®à¤¨à¥à¤¸à¥à¤®à¤°à¤¨à¥ à¤ªà¤°à¤®à¤¾à¤‚ à¤—à¤¤à¤¿à¤‚ à¤ªà¥à¤°à¤¾à¤ªà¥à¤¨à¥‹à¤¤à¤¿à¥¤</a:t>
             </a:r>
             <a:endParaRPr lang="en-US" sz="1050" dirty="0"/>
           </a:p>
@@ -8186,7 +8186,7 @@
                 <a:ea typeface="Tiro Devanagari Sanskrit" pitchFamily="34" charset="-122"/>
                 <a:cs typeface="Tiro Devanagari Sanskrit" pitchFamily="34" charset="-120"/>
               </a:rPr>
-              <a:t>अक्षराणामकारः</a:t>
+              <a:t>à¤…à¤•à¥à¤·à¤°à¤¾à¤£à¤¾à¤®à¤•à¤¾à¤°à¤ƒ</a:t>
             </a:r>
             <a:endParaRPr lang="en-US" sz="1300" dirty="0"/>
           </a:p>
@@ -8267,7 +8267,7 @@
                 <a:ea typeface="Tiro Devanagari Sanskrit" pitchFamily="34" charset="-122"/>
                 <a:cs typeface="Tiro Devanagari Sanskrit" pitchFamily="34" charset="-120"/>
               </a:rPr>
-              <a:t>"अक्षराणामकारोऽस्मि" — सर्ववर्णानां मूलभूतः अकारः अहम् इति कृष्णवचनम्; समासेषु द्वन्द्वसमासश्च।</a:t>
+              <a:t>"à¤…à¤•à¥à¤·à¤°à¤¾à¤£à¤¾à¤®à¤•à¤¾à¤°à¥‹à¤½à¤¸à¥à¤®à¤¿" â€” à¤¸à¤°à¥à¤µà¤µà¤°à¥à¤£à¤¾à¤¨à¤¾à¤‚ à¤®à¥‚à¤²à¤­à¥‚à¤¤à¤ƒ à¤…à¤•à¤¾à¤°à¤ƒ à¤…à¤¹à¤®à¥ à¤‡à¤¤à¤¿ à¤•à¥ƒà¤·à¥à¤£à¤µà¤šà¤¨à¤®à¥; à¤¸à¤®à¤¾à¤¸à¥‡à¤·à¥ à¤¦à¥à¤µà¤¨à¥à¤¦à¥à¤µà¤¸à¤®à¤¾à¤¸à¤¶à¥à¤š…</a:t>
             </a:r>
             <a:endParaRPr lang="en-US" sz="1050" dirty="0"/>
           </a:p>
@@ -9144,7 +9144,7 @@
                 <a:ea typeface="Tiro Devanagari Sanskrit" pitchFamily="34" charset="-122"/>
                 <a:cs typeface="Tiro Devanagari Sanskrit" pitchFamily="34" charset="-120"/>
               </a:rPr>
-              <a:t>परमार्थ</a:t>
+              <a:t>à¤ªà¤°à¤®à¤¾à¤°à¥à¤¥</a:t>
             </a:r>
             <a:endParaRPr lang="en-US" sz="800" dirty="0"/>
           </a:p>
@@ -9433,7 +9433,7 @@
                 <a:ea typeface="Tiro Devanagari Sanskrit" pitchFamily="34" charset="-122"/>
                 <a:cs typeface="Tiro Devanagari Sanskrit" pitchFamily="34" charset="-120"/>
               </a:rPr>
-              <a:t>तत्त्व</a:t>
+              <a:t>à¤¤à¤¤à¥à¤¤à¥à¤µ</a:t>
             </a:r>
             <a:endParaRPr lang="en-US" sz="800" dirty="0"/>
           </a:p>
@@ -9672,7 +9672,7 @@
                 <a:ea typeface="Tiro Devanagari Sanskrit" pitchFamily="34" charset="-122"/>
                 <a:cs typeface="Tiro Devanagari Sanskrit" pitchFamily="34" charset="-120"/>
               </a:rPr>
-              <a:t>क्षेत्र-क्षेत्रज्ञ</a:t>
+              <a:t>à¤•à¥à¤·à¥‡à¤¤à¥à¤°-à¤•à¥à¤·à¥‡à¤¤à¥à¤°à¤œà¥à¤ž</a:t>
             </a:r>
             <a:endParaRPr lang="en-US" sz="800" dirty="0"/>
           </a:p>
@@ -9911,7 +9911,7 @@
                 <a:ea typeface="Tiro Devanagari Sanskrit" pitchFamily="34" charset="-122"/>
                 <a:cs typeface="Tiro Devanagari Sanskrit" pitchFamily="34" charset="-120"/>
               </a:rPr>
-              <a:t>गुण</a:t>
+              <a:t>à¤—à¥à¤£</a:t>
             </a:r>
             <a:endParaRPr lang="en-US" sz="800" dirty="0"/>
           </a:p>
@@ -10200,7 +10200,7 @@
                 <a:ea typeface="Tiro Devanagari Sanskrit" pitchFamily="34" charset="-122"/>
                 <a:cs typeface="Tiro Devanagari Sanskrit" pitchFamily="34" charset="-120"/>
               </a:rPr>
-              <a:t>योग</a:t>
+              <a:t>à¤¯à¥‹à¤—</a:t>
             </a:r>
             <a:endParaRPr lang="en-US" sz="800" dirty="0"/>
           </a:p>
@@ -10464,7 +10464,7 @@
                 <a:ea typeface="Tiro Devanagari Sanskrit" pitchFamily="34" charset="-122"/>
                 <a:cs typeface="Tiro Devanagari Sanskrit" pitchFamily="34" charset="-120"/>
               </a:rPr>
-              <a:t>साधना</a:t>
+              <a:t>à¤¸à¤¾à¤§à¤¨à¤¾</a:t>
             </a:r>
             <a:endParaRPr lang="en-US" sz="800" dirty="0"/>
           </a:p>
@@ -10753,7 +10753,7 @@
                 <a:ea typeface="Tiro Devanagari Sanskrit" pitchFamily="34" charset="-122"/>
                 <a:cs typeface="Tiro Devanagari Sanskrit" pitchFamily="34" charset="-120"/>
               </a:rPr>
-              <a:t>अन्तःकरण</a:t>
+              <a:t>à¤…à¤¨à¥à¤¤à¤ƒà¤•à¤°à¤£</a:t>
             </a:r>
             <a:endParaRPr lang="en-US" sz="800" dirty="0"/>
           </a:p>
@@ -10942,7 +10942,7 @@
                 <a:ea typeface="Tiro Devanagari Sanskrit" pitchFamily="34" charset="-122"/>
                 <a:cs typeface="Tiro Devanagari Sanskrit" pitchFamily="34" charset="-120"/>
               </a:rPr>
-              <a:t>धर्म</a:t>
+              <a:t>à¤§à¤°à¥à¤®</a:t>
             </a:r>
             <a:endParaRPr lang="en-US" sz="800" dirty="0"/>
           </a:p>
@@ -11206,7 +11206,7 @@
                 <a:ea typeface="Tiro Devanagari Sanskrit" pitchFamily="34" charset="-122"/>
                 <a:cs typeface="Tiro Devanagari Sanskrit" pitchFamily="34" charset="-120"/>
               </a:rPr>
-              <a:t>दोष</a:t>
+              <a:t>à¤¦à¥‹à¤·</a:t>
             </a:r>
             <a:endParaRPr lang="en-US" sz="800" dirty="0"/>
           </a:p>
@@ -11445,7 +11445,7 @@
                 <a:ea typeface="Tiro Devanagari Sanskrit" pitchFamily="34" charset="-122"/>
                 <a:cs typeface="Tiro Devanagari Sanskrit" pitchFamily="34" charset="-120"/>
               </a:rPr>
-              <a:t>फल</a:t>
+              <a:t>à¤«à¤²</a:t>
             </a:r>
             <a:endParaRPr lang="en-US" sz="800" dirty="0"/>
           </a:p>
@@ -11734,7 +11734,7 @@
                 <a:ea typeface="Tiro Devanagari Sanskrit" pitchFamily="34" charset="-122"/>
                 <a:cs typeface="Tiro Devanagari Sanskrit" pitchFamily="34" charset="-120"/>
               </a:rPr>
-              <a:t>यज्ञ</a:t>
+              <a:t>à¤¯à¤œà¥à¤ž</a:t>
             </a:r>
             <a:endParaRPr lang="en-US" sz="800" dirty="0"/>
           </a:p>
@@ -11923,7 +11923,7 @@
                 <a:ea typeface="Tiro Devanagari Sanskrit" pitchFamily="34" charset="-122"/>
                 <a:cs typeface="Tiro Devanagari Sanskrit" pitchFamily="34" charset="-120"/>
               </a:rPr>
-              <a:t>प्रतीक</a:t>
+              <a:t>à¤ªà¥à¤°à¤¤à¥€à¤•</a:t>
             </a:r>
             <a:endParaRPr lang="en-US" sz="800" dirty="0"/>
           </a:p>
@@ -12183,7 +12183,7 @@
                 <a:ea typeface="Tiro Devanagari Sanskrit" pitchFamily="34" charset="-122"/>
                 <a:cs typeface="Tiro Devanagari Sanskrit" pitchFamily="34" charset="-120"/>
               </a:rPr>
-              <a:t>सर्वोत्तमत्वम् — हरेः</a:t>
+              <a:t>à¤¸à¤°à¥à¤µà¥‹à¤¤à¥à¤¤à¤®à¤¤à¥à¤µà¤®à¥ â€” à¤¹à¤°à¥‡à¤ƒ</a:t>
             </a:r>
             <a:endParaRPr lang="en-US" sz="3000" dirty="0"/>
           </a:p>
@@ -12225,7 +12225,7 @@
                 <a:ea typeface="Tiro Devanagari Sanskrit" pitchFamily="34" charset="-122"/>
                 <a:cs typeface="Tiro Devanagari Sanskrit" pitchFamily="34" charset="-120"/>
               </a:rPr>
-              <a:t>तारतम्यस्य मूलाधार-सिद्धान्तः — हरिः सर्वोत्कृष्टः, न तस्य समः न अधिकः। सर्वम् इतरत् तत्-परतन्त्रम्।</a:t>
+              <a:t>à¤¤à¤¾à¤°à¤¤à¤®à¥à¤¯à¤¸à¥à¤¯ à¤®à¥‚à¤²à¤¾à¤§à¤¾à¤°-à¤¸à¤¿à¤¦à¥à¤§à¤¾à¤¨à¥à¤¤à¤ƒ â€” à¤¹à¤°à¤¿à¤ƒ à¤¸à¤°à¥à¤µà¥‹à¤¤à¥à¤•à¥ƒà¤·à¥à¤Ÿà¤ƒ, à¤¨ à¤¤à¤¸à¥à¤¯ à¤¸à¤®à¤ƒ à¤¨ à¤…à¤§à¤¿à¤•à¤ƒà¥¤ à¤¸à¤°à¥à¤µà¤®à¥ à¤‡à¤¤à¤°à¤¤à¥ à¤¤à¤¤à¥-à¤ªà¤°à¤¤à¤¨à¥à¤¤à¥à¤°à¤®à¥à¥¤</a:t>
             </a:r>
             <a:endParaRPr lang="en-US" sz="1300" dirty="0"/>
           </a:p>
@@ -12267,7 +12267,7 @@
                 <a:ea typeface="Tiro Devanagari Sanskrit" pitchFamily="34" charset="-122"/>
                 <a:cs typeface="Tiro Devanagari Sanskrit" pitchFamily="34" charset="-120"/>
               </a:rPr>
-              <a:t>मध्व-सिद्धान्तस्य आधार-शिला — पञ्च-भेद-व्यवस्था अत एव प्रारभते।</a:t>
+              <a:t>à¤®à¤§à¥à¤µ-à¤¸à¤¿à¤¦à¥à¤§à¤¾à¤¨à¥à¤¤à¤¸à¥à¤¯ à¤†à¤§à¤¾à¤°-à¤¶à¤¿à¤²à¤¾ â€” à¤ªà¤žà¥à¤š-à¤­à¥‡à¤¦-à¤µà¥à¤¯à¤µà¤¸à¥à¤¥à¤¾ à¤…à¤¤ à¤à¤µ à¤ªà¥à¤°à¤¾à¤°à¤­à¤¤à¥‡à¥¤</a:t>
             </a:r>
             <a:endParaRPr lang="en-US" sz="1300" dirty="0"/>
           </a:p>
@@ -12437,7 +12437,7 @@
                 <a:ea typeface="Tiro Devanagari Sanskrit" pitchFamily="34" charset="-122"/>
                 <a:cs typeface="Tiro Devanagari Sanskrit" pitchFamily="34" charset="-120"/>
               </a:rPr>
-              <a:t>मत्तः परतरं नान्यत्किञ्चिदस्ति धनञ्जय।</a:t>
+              <a:t>à¤®à¤¤à¥à¤¤à¤ƒ à¤ªà¤°à¤¤à¤°à¤‚ à¤¨à¤¾à¤¨à¥à¤¯à¤¤à¥à¤•à¤¿à¤žà¥à¤šà¤¿à¤¦à¤¸à¥à¤¤à¤¿ à¤§à¤¨à¤žà¥à¤œà¤¯à¥¤</a:t>
             </a:r>
             <a:endParaRPr lang="en-US" sz="1200" dirty="0"/>
           </a:p>
@@ -12476,7 +12476,7 @@
                 <a:ea typeface="Cormorant Garamond" pitchFamily="34" charset="-122"/>
                 <a:cs typeface="Cormorant Garamond" pitchFamily="34" charset="-120"/>
               </a:rPr>
-              <a:t>BG 7.7 · 11.43 · 18.65</a:t>
+              <a:t>BG 7.7 Â· 11.43 Â· 18.65</a:t>
             </a:r>
             <a:endParaRPr lang="en-US" sz="1000" dirty="0"/>
           </a:p>
@@ -12586,7 +12586,7 @@
                 <a:ea typeface="Tiro Devanagari Sanskrit" pitchFamily="34" charset="-122"/>
                 <a:cs typeface="Tiro Devanagari Sanskrit" pitchFamily="34" charset="-120"/>
               </a:rPr>
-              <a:t>पञ्चभेदः — पञ्च-वास्तविक-भेदाः</a:t>
+              <a:t>à¤ªà¤žà¥à¤šà¤­à¥‡à¤¦à¤ƒ â€” à¤ªà¤žà¥à¤š-à¤µà¤¾à¤¸à¥à¤¤à¤µà¤¿à¤•-à¤­à¥‡à¤¦à¤¾à¤ƒ</a:t>
             </a:r>
             <a:endParaRPr lang="en-US" sz="3000" dirty="0"/>
           </a:p>
@@ -12628,7 +12628,7 @@
                 <a:ea typeface="Tiro Devanagari Sanskrit" pitchFamily="34" charset="-122"/>
                 <a:cs typeface="Tiro Devanagari Sanskrit" pitchFamily="34" charset="-120"/>
               </a:rPr>
-              <a:t>हरि-जीव, हरि-जड, जीव-जड, जीव-जीव, जड-जड — एते पञ्च नित्य-भेदाः मध्व-सिद्धान्तेन सत्ता-तन्त्र-वास्तविकाः इति प्रतिपाद्यन्ते।</a:t>
+              <a:t>à¤¹à¤°à¤¿-à¤œà¥€à¤µ, à¤¹à¤°à¤¿-à¤œà¤¡, à¤œà¥€à¤µ-à¤œà¤¡, à¤œà¥€à¤µ-à¤œà¥€à¤µ, à¤œà¤¡-à¤œà¤¡ â€” à¤à¤¤à¥‡ à¤ªà¤žà¥à¤š à¤¨à¤¿à¤¤à¥à¤¯-à¤­à¥‡à¤¦à¤¾à¤ƒ à¤®à¤§à¥à¤µ-à¤¸à¤¿à¤¦à¥à¤§à¤¾à¤¨à¥à¤¤à¥‡à¤¨ à¤¸à¤¤à¥à¤¤à¤¾-à¤¤à¤¨à¥à¤¤à¥à¤°-à¤µà¤¾à¤¸à¥à¤¤à¤µà¤¿à¤•à¤¾à¤ƒ à¤‡à¤¤à¤¿ à¤ªà¥à¤°à¤¤à¤¿à¤ªà¤¾à¤¦à¥à¤¯à¤¨à¥à¤¤à¥‡à¥¤</a:t>
             </a:r>
             <a:endParaRPr lang="en-US" sz="1300" dirty="0"/>
           </a:p>
@@ -12670,7 +12670,7 @@
                 <a:ea typeface="Tiro Devanagari Sanskrit" pitchFamily="34" charset="-122"/>
                 <a:cs typeface="Tiro Devanagari Sanskrit" pitchFamily="34" charset="-120"/>
               </a:rPr>
-              <a:t>मध्व-निर्णायकम्। प्रत्येक-भेदः गीतायां प्रतिष्ठितः (जीवांश-वाक्यं गी॰ १५।७; जीव-जीव-भेदः स्वभाव-वाक्ये गी॰ १८।४१ इत्यादिषु अन्तर्निहितः)।</a:t>
+              <a:t>à¤®à¤§à¥à¤µ-à¤¨à¤¿à¤°à¥à¤£à¤¾à¤¯à¤•à¤®à¥à¥¤ à¤ªà¥à¤°à¤¤à¥à¤¯à¥‡à¤•-à¤­à¥‡à¤¦à¤ƒ à¤—à¥€à¤¤à¤¾à¤¯à¤¾à¤‚ à¤ªà¥à¤°à¤¤à¤¿à¤·à¥à¤ à¤¿à¤¤à¤ƒ (à¤œà¥€à¤µà¤¾à¤‚à¤¶-à¤µà¤¾à¤•à¥à¤¯à¤‚ à¤—à¥€à¥° à¥§à¥«à¥¤à¥­; à¤œà¥€à¤µ-à¤œà¥€à¤µ-à¤­à¥‡à¤¦à¤ƒ à¤¸à¥à¤µà¤­à¤¾à¤µ-à¤µà¤¾à¤•à¥à¤¯à¥‡ à¤—à¥€à¥° à¥§à¥®à¥¤à¥ªà¥§ à¤‡à¤¤à¥à¤¯à¤¾à¤¦à¤¿à¤·à¥ à¤…à¤¨à¥à¤¤à¤°à¥à¤¨à¤¿à¤¹à¤¿à¤¤à¤ƒ)à¥¤</a:t>
             </a:r>
             <a:endParaRPr lang="en-US" sz="1300" dirty="0"/>
           </a:p>
@@ -12840,7 +12840,7 @@
                 <a:ea typeface="Tiro Devanagari Sanskrit" pitchFamily="34" charset="-122"/>
                 <a:cs typeface="Tiro Devanagari Sanskrit" pitchFamily="34" charset="-120"/>
               </a:rPr>
-              <a:t>ममैवांशो जीवलोके जीवभूतः सनातनः।</a:t>
+              <a:t>à¤®à¤®à¥ˆà¤µà¤¾à¤‚à¤¶à¥‹ à¤œà¥€à¤µà¤²à¥‹à¤•à¥‡ à¤œà¥€à¤µà¤­à¥‚à¤¤à¤ƒ à¤¸à¤¨à¤¾à¤¤à¤¨à¤ƒà¥¤</a:t>
             </a:r>
             <a:endParaRPr lang="en-US" sz="1200" dirty="0"/>
           </a:p>
@@ -12879,7 +12879,7 @@
                 <a:ea typeface="Cormorant Garamond" pitchFamily="34" charset="-122"/>
                 <a:cs typeface="Cormorant Garamond" pitchFamily="34" charset="-120"/>
               </a:rPr>
-              <a:t>BG 7.4–5 · 15.7 · 15.16–18</a:t>
+              <a:t>BG 7.4â€“5 Â· 15.7 Â· 15.16â€“18</a:t>
             </a:r>
             <a:endParaRPr lang="en-US" sz="1000" dirty="0"/>
           </a:p>
@@ -13141,7 +13141,7 @@
                 <a:ea typeface="Tiro Devanagari Sanskrit" pitchFamily="34" charset="-122"/>
                 <a:cs typeface="Tiro Devanagari Sanskrit" pitchFamily="34" charset="-120"/>
               </a:rPr>
-              <a:t>तारतम्यम् — सत्ता-क्रमः</a:t>
+              <a:t>à¤¤à¤¾à¤°à¤¤à¤®à¥à¤¯à¤®à¥ â€” à¤¸à¤¤à¥à¤¤à¤¾-à¤•à¥à¤°à¤®à¤ƒ</a:t>
             </a:r>
             <a:endParaRPr lang="en-US" sz="3000" dirty="0"/>
           </a:p>
@@ -13183,7 +13183,7 @@
                 <a:ea typeface="Tiro Devanagari Sanskrit" pitchFamily="34" charset="-122"/>
                 <a:cs typeface="Tiro Devanagari Sanskrit" pitchFamily="34" charset="-120"/>
               </a:rPr>
-              <a:t>हरि-अधीनस्य समस्त-सत्तायाः कठोर-क्रम-व्यवस्था — प्रत्येक-जीवस्य निश्चितः अपरिवर्तनीयः च पद-क्रमः। मध्व-तत्त्व-शास्त्रस्य रचना-तत्त्वम्।</a:t>
+              <a:t>à¤¹à¤°à¤¿-à¤…à¤§à¥€à¤¨à¤¸à¥à¤¯ à¤¸à¤®à¤¸à¥à¤¤-à¤¸à¤¤à¥à¤¤à¤¾à¤¯à¤¾à¤ƒ à¤•à¤ à¥‹à¤°-à¤•à¥à¤°à¤®-à¤µà¥à¤¯à¤µà¤¸à¥à¤¥à¤¾ â€” à¤ªà¥à¤°à¤¤à¥à¤¯à¥‡à¤•-à¤œà¥€à¤µà¤¸à¥à¤¯ à¤¨à¤¿à¤¶à¥à¤šà¤¿à¤¤à¤ƒ à¤…à¤ªà¤°à¤¿à¤µà¤°à¥à¤¤à¤¨à¥€à¤¯à¤ƒ à¤š à¤ªà¤¦-à¤•à¥à¤°à¤®à¤ƒà¥¤ à¤®à¤§à¥à¤µ-à¤¤à¤¤à¥à¤¤à¥à¤µ-à¤¶à¤¾à¤¸à¥à¤¤à¥à¤°à¤¸à¥à¤¯ à¤°à¤šà¤¨à¤¾-à¤¤à¤¤à¥à¤¤à¥à¤µà¤®à¥à¥¤</a:t>
             </a:r>
             <a:endParaRPr lang="en-US" sz="1300" dirty="0"/>
           </a:p>
@@ -13225,7 +13225,7 @@
                 <a:ea typeface="Tiro Devanagari Sanskrit" pitchFamily="34" charset="-122"/>
                 <a:cs typeface="Tiro Devanagari Sanskrit" pitchFamily="34" charset="-120"/>
               </a:rPr>
-              <a:t>विशिष्टं मध्व-तत्त्वम्। पञ्च-भेद-व्यवस्थां मुक्ति-तारतम्यं च आधारयति।</a:t>
+              <a:t>à¤µà¤¿à¤¶à¤¿à¤·à¥à¤Ÿà¤‚ à¤®à¤§à¥à¤µ-à¤¤à¤¤à¥à¤¤à¥à¤µà¤®à¥à¥¤ à¤ªà¤žà¥à¤š-à¤­à¥‡à¤¦-à¤µà¥à¤¯à¤µà¤¸à¥à¤¥à¤¾à¤‚ à¤®à¥à¤•à¥à¤¤à¤¿-à¤¤à¤¾à¤°à¤¤à¤®à¥à¤¯à¤‚ à¤š à¤†à¤§à¤¾à¤°à¤¯à¤¤à¤¿à¥¤</a:t>
             </a:r>
             <a:endParaRPr lang="en-US" sz="1300" dirty="0"/>
           </a:p>
@@ -13395,7 +13395,7 @@
                 <a:ea typeface="Tiro Devanagari Sanskrit" pitchFamily="34" charset="-122"/>
                 <a:cs typeface="Tiro Devanagari Sanskrit" pitchFamily="34" charset="-120"/>
               </a:rPr>
-              <a:t>मत्तः परतरं नान्यत्किञ्चिदस्ति धनञ्जय।</a:t>
+              <a:t>à¤®à¤¤à¥à¤¤à¤ƒ à¤ªà¤°à¤¤à¤°à¤‚ à¤¨à¤¾à¤¨à¥à¤¯à¤¤à¥à¤•à¤¿à¤žà¥à¤šà¤¿à¤¦à¤¸à¥à¤¤à¤¿ à¤§à¤¨à¤žà¥à¤œà¤¯à¥¤</a:t>
             </a:r>
             <a:endParaRPr lang="en-US" sz="1200" dirty="0"/>
           </a:p>
@@ -13415,7 +13415,7 @@
                 <a:ea typeface="Tiro Devanagari Sanskrit" pitchFamily="34" charset="-122"/>
                 <a:cs typeface="Tiro Devanagari Sanskrit" pitchFamily="34" charset="-120"/>
               </a:rPr>
-              <a:t>मयि सर्वमिदं प्रोतं सूत्रे मणिगणा इव॥</a:t>
+              <a:t>à¤®à¤¯à¤¿ à¤¸à¤°à¥à¤µà¤®à¤¿à¤¦à¤‚ à¤ªà¥à¤°à¥‹à¤¤à¤‚ à¤¸à¥‚à¤¤à¥à¤°à¥‡ à¤®à¤£à¤¿à¤—à¤£à¤¾ à¤‡à¤µà¥¥</a:t>
             </a:r>
             <a:endParaRPr lang="en-US" sz="1200" dirty="0"/>
           </a:p>
@@ -13454,7 +13454,7 @@
                 <a:ea typeface="Cormorant Garamond" pitchFamily="34" charset="-122"/>
                 <a:cs typeface="Cormorant Garamond" pitchFamily="34" charset="-120"/>
               </a:rPr>
-              <a:t>BG 7.7 · 15.16–18</a:t>
+              <a:t>BG 7.7 Â· 15.16â€“18</a:t>
             </a:r>
             <a:endParaRPr lang="en-US" sz="1000" dirty="0"/>
           </a:p>
@@ -13564,7 +13564,7 @@
                 <a:ea typeface="Tiro Devanagari Sanskrit" pitchFamily="34" charset="-122"/>
                 <a:cs typeface="Tiro Devanagari Sanskrit" pitchFamily="34" charset="-120"/>
               </a:rPr>
-              <a:t>चरमश्लोकफलम्</a:t>
+              <a:t>à¤šà¤°à¤®à¤¶à¥à¤²à¥‹à¤•à¤«à¤²à¤®à¥</a:t>
             </a:r>
             <a:endParaRPr lang="en-US" sz="3000" dirty="0"/>
           </a:p>
@@ -13606,7 +13606,7 @@
                 <a:ea typeface="Tiro Devanagari Sanskrit" pitchFamily="34" charset="-122"/>
                 <a:cs typeface="Tiro Devanagari Sanskrit" pitchFamily="34" charset="-120"/>
               </a:rPr>
-              <a:t>"अहं त्वा सर्वपापेभ्यो मोक्षयिष्यामि मा शुचः" — अष्टादशाध्याये कृष्णस्य प्रत्यक्षाश्वासः। माध्वसम्प्रदाये अयं गीताशास्त्रस्य शिरोभूतः श्लोकः।</a:t>
+              <a:t>"à¤…à¤¹à¤‚ à¤¤à¥à¤µà¤¾ à¤¸à¤°à¥à¤µà¤ªà¤¾à¤ªà¥‡à¤­à¥à¤¯à¥‹ à¤®à¥‹à¤•à¥à¤·à¤¯à¤¿à¤·à¥à¤¯à¤¾à¤®à¤¿ à¤®à¤¾ à¤¶à¥à¤šà¤ƒ" â€” à¤…à¤·à¥à¤Ÿà¤¾à¤¦à¤¶à¤¾à¤§à¥à¤¯à¤¾à¤¯à¥‡ à¤•à¥ƒà¤·à¥à¤£à¤¸à¥à¤¯ à¤ªà¥à¤°à¤¤à¥à¤¯à¤•à¥à¤·à¤¾à¤¶à¥à¤µà¤¾à¤¸à¤ƒà¥¤ à¤®à¤¾à¤§à¥à¤µà¤¸à¤®à¥à¤ªà¥à¤°à¤¦à¤¾à¤¯à¥‡ à¤…à¤¯à¤‚ à¤—à¥€à¤¤à¤¾à¤¶à¤¾à¤¸à¥à¤¤à¥à¤°à¤¸à¥à¤¯ à¤¶à¤¿à¤°à¥‹à¤­à¥‚à¤¤à¤ƒ à¤¶à¥à¤²à¥‹à¤•à¤ƒà¥¤</a:t>
             </a:r>
             <a:endParaRPr lang="en-US" sz="1300" dirty="0"/>
           </a:p>
@@ -13648,7 +13648,7 @@
                 <a:ea typeface="Tiro Devanagari Sanskrit" pitchFamily="34" charset="-122"/>
                 <a:cs typeface="Tiro Devanagari Sanskrit" pitchFamily="34" charset="-120"/>
               </a:rPr>
-              <a:t>चरमश्लोकः — मध्वाचार्यस्य साक्षात् मोक्षोपदेशः।</a:t>
+              <a:t>à¤šà¤°à¤®à¤¶à¥à¤²à¥‹à¤•à¤ƒ â€” à¤®à¤§à¥à¤µà¤¾à¤šà¤¾à¤°à¥à¤¯à¤¸à¥à¤¯ à¤¸à¤¾à¤•à¥à¤·à¤¾à¤¤à¥ à¤®à¥‹à¤•à¥à¤·à¥‹à¤ªà¤¦à¥‡à¤¶à¤ƒà¥¤</a:t>
             </a:r>
             <a:endParaRPr lang="en-US" sz="1300" dirty="0"/>
           </a:p>
@@ -13818,7 +13818,7 @@
                 <a:ea typeface="Tiro Devanagari Sanskrit" pitchFamily="34" charset="-122"/>
                 <a:cs typeface="Tiro Devanagari Sanskrit" pitchFamily="34" charset="-120"/>
               </a:rPr>
-              <a:t>सर्वधर्मान्परित्यज्य मामेकं शरणं व्रज।</a:t>
+              <a:t>à¤¸à¤°à¥à¤µà¤§à¤°à¥à¤®à¤¾à¤¨à¥à¤ªà¤°à¤¿à¤¤à¥à¤¯à¤œà¥à¤¯ à¤®à¤¾à¤®à¥‡à¤•à¤‚ à¤¶à¤°à¤£à¤‚ à¤µà¥à¤°à¤œà¥¤</a:t>
             </a:r>
             <a:endParaRPr lang="en-US" sz="1200" dirty="0"/>
           </a:p>
@@ -13838,7 +13838,7 @@
                 <a:ea typeface="Tiro Devanagari Sanskrit" pitchFamily="34" charset="-122"/>
                 <a:cs typeface="Tiro Devanagari Sanskrit" pitchFamily="34" charset="-120"/>
               </a:rPr>
-              <a:t>अहं त्वा सर्वपापेभ्यो मोक्षयिष्यामि मा शुचः॥</a:t>
+              <a:t>à¤…à¤¹à¤‚ à¤¤à¥à¤µà¤¾ à¤¸à¤°à¥à¤µà¤ªà¤¾à¤ªà¥‡à¤­à¥à¤¯à¥‹ à¤®à¥‹à¤•à¥à¤·à¤¯à¤¿à¤·à¥à¤¯à¤¾à¤®à¤¿ à¤®à¤¾ à¤¶à¥à¤šà¤ƒà¥¥</a:t>
             </a:r>
             <a:endParaRPr lang="en-US" sz="1200" dirty="0"/>
           </a:p>
@@ -13987,7 +13987,7 @@
                 <a:ea typeface="Tiro Devanagari Sanskrit" pitchFamily="34" charset="-122"/>
                 <a:cs typeface="Tiro Devanagari Sanskrit" pitchFamily="34" charset="-120"/>
               </a:rPr>
-              <a:t>जीवः — देहस्थः आत्मा</a:t>
+              <a:t>à¤œà¥€à¤µà¤ƒ â€” à¤¦à¥‡à¤¹à¤¸à¥à¤¥à¤ƒ à¤†à¤¤à¥à¤®à¤¾</a:t>
             </a:r>
             <a:endParaRPr lang="en-US" sz="3000" dirty="0"/>
           </a:p>
@@ -14029,7 +14029,7 @@
                 <a:ea typeface="Tiro Devanagari Sanskrit" pitchFamily="34" charset="-122"/>
                 <a:cs typeface="Tiro Devanagari Sanskrit" pitchFamily="34" charset="-120"/>
               </a:rPr>
-              <a:t>हरेः नित्यः अंशः (गी॰ १५।७) — सत्यः, भिन्नः, बहुविधः, कदापि ब्रह्मणि लीनं न प्राप्नोति। मुक्ति-पर्यन्तम् अविद्यया बद्धः।</a:t>
+              <a:t>à¤¹à¤°à¥‡à¤ƒ à¤¨à¤¿à¤¤à¥à¤¯à¤ƒ à¤…à¤‚à¤¶à¤ƒ (à¤—à¥€à¥° à¥§à¥«à¥¤à¥­) â€” à¤¸à¤¤à¥à¤¯à¤ƒ, à¤­à¤¿à¤¨à¥à¤¨à¤ƒ, à¤¬à¤¹à¥à¤µà¤¿à¤§à¤ƒ, à¤•à¤¦à¤¾à¤ªà¤¿ à¤¬à¥à¤°à¤¹à¥à¤®à¤£à¤¿ à¤²à¥€à¤¨à¤‚ à¤¨ à¤ªà¥à¤°à¤¾à¤ªà¥à¤¨à¥‹à¤¤à¤¿à¥¤ à¤®à¥à¤•à¥à¤¤à¤¿-à¤ªà¤°à¥à¤¯à¤¨à¥à¤¤à¤®à¥ à¤…à¤µà¤¿à¤¦à¥à¤¯à¤¯à¤¾ à¤¬à¤¦à¥à¤§à¤ƒà¥¤</a:t>
             </a:r>
             <a:endParaRPr lang="en-US" sz="1300" dirty="0"/>
           </a:p>
@@ -14071,7 +14071,7 @@
                 <a:ea typeface="Tiro Devanagari Sanskrit" pitchFamily="34" charset="-122"/>
                 <a:cs typeface="Tiro Devanagari Sanskrit" pitchFamily="34" charset="-120"/>
               </a:rPr>
-              <a:t>जीव-भेदः वास्तविकः (पञ्च-भेदेषु प्रथमः)। जीव-बहुत्वं नित्यम्।</a:t>
+              <a:t>à¤œà¥€à¤µ-à¤­à¥‡à¤¦à¤ƒ à¤µà¤¾à¤¸à¥à¤¤à¤µà¤¿à¤•à¤ƒ (à¤ªà¤žà¥à¤š-à¤­à¥‡à¤¦à¥‡à¤·à¥ à¤ªà¥à¤°à¤¥à¤®à¤ƒ)à¥¤ à¤œà¥€à¤µ-à¤¬à¤¹à¥à¤¤à¥à¤µà¤‚ à¤¨à¤¿à¤¤à¥à¤¯à¤®à¥à¥¤</a:t>
             </a:r>
             <a:endParaRPr lang="en-US" sz="1300" dirty="0"/>
           </a:p>
@@ -14241,7 +14241,7 @@
                 <a:ea typeface="Tiro Devanagari Sanskrit" pitchFamily="34" charset="-122"/>
                 <a:cs typeface="Tiro Devanagari Sanskrit" pitchFamily="34" charset="-120"/>
               </a:rPr>
-              <a:t>ममैवांशो जीवलोके जीवभूतः सनातनः।</a:t>
+              <a:t>à¤®à¤®à¥ˆà¤µà¤¾à¤‚à¤¶à¥‹ à¤œà¥€à¤µà¤²à¥‹à¤•à¥‡ à¤œà¥€à¤µà¤­à¥‚à¤¤à¤ƒ à¤¸à¤¨à¤¾à¤¤à¤¨à¤ƒà¥¤</a:t>
             </a:r>
             <a:endParaRPr lang="en-US" sz="1200" dirty="0"/>
           </a:p>
@@ -14261,7 +14261,7 @@
                 <a:ea typeface="Tiro Devanagari Sanskrit" pitchFamily="34" charset="-122"/>
                 <a:cs typeface="Tiro Devanagari Sanskrit" pitchFamily="34" charset="-120"/>
               </a:rPr>
-              <a:t>मनःषष्ठानीन्द्रियाणि प्रकृतिस्थानि कर्षति॥</a:t>
+              <a:t>à¤®à¤¨à¤ƒà¤·à¤·à¥à¤ à¤¾à¤¨à¥€à¤¨à¥à¤¦à¥à¤°à¤¿à¤¯à¤¾à¤£à¤¿ à¤ªà¥à¤°à¤•à¥ƒà¤¤à¤¿à¤¸à¥à¤¥à¤¾à¤¨à¤¿ à¤•à¤°à¥à¤·à¤¤à¤¿à¥¥</a:t>
             </a:r>
             <a:endParaRPr lang="en-US" sz="1200" dirty="0"/>
           </a:p>
@@ -15026,7 +15026,7 @@
                 <a:ea typeface="Cormorant Garamond" pitchFamily="34" charset="-122"/>
                 <a:cs typeface="Cormorant Garamond" pitchFamily="34" charset="-120"/>
               </a:rPr>
-              <a:t>124</a:t>
+              <a:t>241</a:t>
             </a:r>
             <a:endParaRPr lang="en-US" sz="6000" dirty="0"/>
           </a:p>
@@ -15232,7 +15232,7 @@
                 <a:ea typeface="Cormorant Garamond" pitchFamily="34" charset="-122"/>
                 <a:cs typeface="Cormorant Garamond" pitchFamily="34" charset="-120"/>
               </a:rPr>
-              <a:t>112</a:t>
+              <a:t>124</a:t>
             </a:r>
             <a:endParaRPr lang="en-US" sz="6000" dirty="0"/>
           </a:p>
@@ -15700,7 +15700,7 @@
                 <a:ea typeface="Tiro Devanagari Sanskrit" pitchFamily="34" charset="-122"/>
                 <a:cs typeface="Tiro Devanagari Sanskrit" pitchFamily="34" charset="-120"/>
               </a:rPr>
-              <a:t>परमार्थ</a:t>
+              <a:t>à¤ªà¤°à¤®à¤¾à¤°à¥à¤¥</a:t>
             </a:r>
             <a:endParaRPr lang="en-US" sz="1300" dirty="0"/>
           </a:p>
@@ -15739,7 +15739,7 @@
                 <a:ea typeface="Cormorant Garamond" pitchFamily="34" charset="-122"/>
                 <a:cs typeface="Cormorant Garamond" pitchFamily="34" charset="-120"/>
               </a:rPr>
-              <a:t>Ultimate reality — Hari, the sarvottama</a:t>
+              <a:t>Ultimate reality â€” Hari, the sarvottama</a:t>
             </a:r>
             <a:endParaRPr lang="en-US" sz="1100" dirty="0"/>
           </a:p>
@@ -15803,7 +15803,7 @@
                 <a:ea typeface="Tiro Devanagari Sanskrit" pitchFamily="34" charset="-122"/>
                 <a:cs typeface="Tiro Devanagari Sanskrit" pitchFamily="34" charset="-120"/>
               </a:rPr>
-              <a:t>तत्त्व</a:t>
+              <a:t>à¤¤à¤¤à¥à¤¤à¥à¤µ</a:t>
             </a:r>
             <a:endParaRPr lang="en-US" sz="1300" dirty="0"/>
           </a:p>
@@ -15842,7 +15842,7 @@
                 <a:ea typeface="Cormorant Garamond" pitchFamily="34" charset="-122"/>
                 <a:cs typeface="Cormorant Garamond" pitchFamily="34" charset="-120"/>
               </a:rPr>
-              <a:t>Metaphysical categories — jīva, prakṛti, kāla</a:t>
+              <a:t>Metaphysical categories â€” jÄ«va, praká¹›ti, kÄla</a:t>
             </a:r>
             <a:endParaRPr lang="en-US" sz="1100" dirty="0"/>
           </a:p>
@@ -15906,7 +15906,7 @@
                 <a:ea typeface="Tiro Devanagari Sanskrit" pitchFamily="34" charset="-122"/>
                 <a:cs typeface="Tiro Devanagari Sanskrit" pitchFamily="34" charset="-120"/>
               </a:rPr>
-              <a:t>क्षेत्र-क्षेत्रज्ञ</a:t>
+              <a:t>à¤•à¥à¤·à¥‡à¤¤à¥à¤°-à¤•à¥à¤·à¥‡à¤¤à¥à¤°à¤œà¥à¤ž</a:t>
             </a:r>
             <a:endParaRPr lang="en-US" sz="1300" dirty="0"/>
           </a:p>
@@ -15945,7 +15945,7 @@
                 <a:ea typeface="Cormorant Garamond" pitchFamily="34" charset="-122"/>
                 <a:cs typeface="Cormorant Garamond" pitchFamily="34" charset="-120"/>
               </a:rPr>
-              <a:t>Field &amp; field-knower — body, knower, 24 elements (Ch 13)</a:t>
+              <a:t>Field &amp; field-knower â€” body, knower, 24 elements (Ch 13)</a:t>
             </a:r>
             <a:endParaRPr lang="en-US" sz="1100" dirty="0"/>
           </a:p>
@@ -16009,7 +16009,7 @@
                 <a:ea typeface="Tiro Devanagari Sanskrit" pitchFamily="34" charset="-122"/>
                 <a:cs typeface="Tiro Devanagari Sanskrit" pitchFamily="34" charset="-120"/>
               </a:rPr>
-              <a:t>गुण</a:t>
+              <a:t>à¤—à¥à¤£</a:t>
             </a:r>
             <a:endParaRPr lang="en-US" sz="1300" dirty="0"/>
           </a:p>
@@ -16048,7 +16048,7 @@
                 <a:ea typeface="Cormorant Garamond" pitchFamily="34" charset="-122"/>
                 <a:cs typeface="Cormorant Garamond" pitchFamily="34" charset="-120"/>
               </a:rPr>
-              <a:t>The three modes of prakṛti — sattva, rajas, tamas</a:t>
+              <a:t>The three modes of praká¹›ti â€” sattva, rajas, tamas</a:t>
             </a:r>
             <a:endParaRPr lang="en-US" sz="1100" dirty="0"/>
           </a:p>
@@ -16112,7 +16112,7 @@
                 <a:ea typeface="Tiro Devanagari Sanskrit" pitchFamily="34" charset="-122"/>
                 <a:cs typeface="Tiro Devanagari Sanskrit" pitchFamily="34" charset="-120"/>
               </a:rPr>
-              <a:t>योग</a:t>
+              <a:t>à¤¯à¥‹à¤—</a:t>
             </a:r>
             <a:endParaRPr lang="en-US" sz="1300" dirty="0"/>
           </a:p>
@@ -16151,7 +16151,7 @@
                 <a:ea typeface="Cormorant Garamond" pitchFamily="34" charset="-122"/>
                 <a:cs typeface="Cormorant Garamond" pitchFamily="34" charset="-120"/>
               </a:rPr>
-              <a:t>Paths — karma, jñāna, bhakti, dhyāna, sannyāsa</a:t>
+              <a:t>Paths â€” karma, jÃ±Äna, bhakti, dhyÄna, sannyÄsa</a:t>
             </a:r>
             <a:endParaRPr lang="en-US" sz="1100" dirty="0"/>
           </a:p>
@@ -16215,7 +16215,7 @@
                 <a:ea typeface="Tiro Devanagari Sanskrit" pitchFamily="34" charset="-122"/>
                 <a:cs typeface="Tiro Devanagari Sanskrit" pitchFamily="34" charset="-120"/>
               </a:rPr>
-              <a:t>साधना</a:t>
+              <a:t>à¤¸à¤¾à¤§à¤¨à¤¾</a:t>
             </a:r>
             <a:endParaRPr lang="en-US" sz="1300" dirty="0"/>
           </a:p>
@@ -16254,7 +16254,7 @@
                 <a:ea typeface="Cormorant Garamond" pitchFamily="34" charset="-122"/>
                 <a:cs typeface="Cormorant Garamond" pitchFamily="34" charset="-120"/>
               </a:rPr>
-              <a:t>Practices — śraddhā, vairāgya, yajña, tapas, tyāga</a:t>
+              <a:t>Practices â€” Å›raddhÄ, vairÄgya, yajÃ±a, tapas, tyÄga</a:t>
             </a:r>
             <a:endParaRPr lang="en-US" sz="1100" dirty="0"/>
           </a:p>
@@ -16318,7 +16318,7 @@
                 <a:ea typeface="Tiro Devanagari Sanskrit" pitchFamily="34" charset="-122"/>
                 <a:cs typeface="Tiro Devanagari Sanskrit" pitchFamily="34" charset="-120"/>
               </a:rPr>
-              <a:t>अन्तःकरण</a:t>
+              <a:t>à¤…à¤¨à¥à¤¤à¤ƒà¤•à¤°à¤£</a:t>
             </a:r>
             <a:endParaRPr lang="en-US" sz="1300" dirty="0"/>
           </a:p>
@@ -16357,7 +16357,7 @@
                 <a:ea typeface="Cormorant Garamond" pitchFamily="34" charset="-122"/>
                 <a:cs typeface="Cormorant Garamond" pitchFamily="34" charset="-120"/>
               </a:rPr>
-              <a:t>Inner instrument — manas, buddhi, ahaṅkāra, indriyas</a:t>
+              <a:t>Inner instrument â€” manas, buddhi, ahaá¹…kÄra, indriyas</a:t>
             </a:r>
             <a:endParaRPr lang="en-US" sz="1100" dirty="0"/>
           </a:p>
@@ -16421,7 +16421,7 @@
                 <a:ea typeface="Tiro Devanagari Sanskrit" pitchFamily="34" charset="-122"/>
                 <a:cs typeface="Tiro Devanagari Sanskrit" pitchFamily="34" charset="-120"/>
               </a:rPr>
-              <a:t>धर्म</a:t>
+              <a:t>à¤§à¤°à¥à¤®</a:t>
             </a:r>
             <a:endParaRPr lang="en-US" sz="1300" dirty="0"/>
           </a:p>
@@ -16460,7 +16460,7 @@
                 <a:ea typeface="Cormorant Garamond" pitchFamily="34" charset="-122"/>
                 <a:cs typeface="Cormorant Garamond" pitchFamily="34" charset="-120"/>
               </a:rPr>
-              <a:t>Ethics — svadharma, niṣkāma-karma, sthita-prajña</a:t>
+              <a:t>Ethics â€” svadharma, niá¹£kÄma-karma, sthita-prajÃ±a</a:t>
             </a:r>
             <a:endParaRPr lang="en-US" sz="1100" dirty="0"/>
           </a:p>
@@ -16524,7 +16524,7 @@
                 <a:ea typeface="Tiro Devanagari Sanskrit" pitchFamily="34" charset="-122"/>
                 <a:cs typeface="Tiro Devanagari Sanskrit" pitchFamily="34" charset="-120"/>
               </a:rPr>
-              <a:t>दोष</a:t>
+              <a:t>à¤¦à¥‹à¤·</a:t>
             </a:r>
             <a:endParaRPr lang="en-US" sz="1300" dirty="0"/>
           </a:p>
@@ -16563,7 +16563,7 @@
                 <a:ea typeface="Cormorant Garamond" pitchFamily="34" charset="-122"/>
                 <a:cs typeface="Cormorant Garamond" pitchFamily="34" charset="-120"/>
               </a:rPr>
-              <a:t>Defects — kāma, krodha, lobha, moha, asat-saṅga</a:t>
+              <a:t>Defects â€” kÄma, krodha, lobha, moha, asat-saá¹…ga</a:t>
             </a:r>
             <a:endParaRPr lang="en-US" sz="1100" dirty="0"/>
           </a:p>
@@ -16627,7 +16627,7 @@
                 <a:ea typeface="Tiro Devanagari Sanskrit" pitchFamily="34" charset="-122"/>
                 <a:cs typeface="Tiro Devanagari Sanskrit" pitchFamily="34" charset="-120"/>
               </a:rPr>
-              <a:t>फल</a:t>
+              <a:t>à¤«à¤²</a:t>
             </a:r>
             <a:endParaRPr lang="en-US" sz="1300" dirty="0"/>
           </a:p>
@@ -16666,7 +16666,7 @@
                 <a:ea typeface="Cormorant Garamond" pitchFamily="34" charset="-122"/>
                 <a:cs typeface="Cormorant Garamond" pitchFamily="34" charset="-120"/>
               </a:rPr>
-              <a:t>Goals &amp; states — mokṣa, paramagati, brāhmī-sthiti</a:t>
+              <a:t>Goals &amp; states â€” moká¹£a, paramagati, brÄhmÄ«-sthiti</a:t>
             </a:r>
             <a:endParaRPr lang="en-US" sz="1100" dirty="0"/>
           </a:p>
@@ -16730,7 +16730,7 @@
                 <a:ea typeface="Tiro Devanagari Sanskrit" pitchFamily="34" charset="-122"/>
                 <a:cs typeface="Tiro Devanagari Sanskrit" pitchFamily="34" charset="-120"/>
               </a:rPr>
-              <a:t>यज्ञ</a:t>
+              <a:t>à¤¯à¤œà¥à¤ž</a:t>
             </a:r>
             <a:endParaRPr lang="en-US" sz="1300" dirty="0"/>
           </a:p>
@@ -16769,7 +16769,7 @@
                 <a:ea typeface="Cormorant Garamond" pitchFamily="34" charset="-122"/>
                 <a:cs typeface="Cormorant Garamond" pitchFamily="34" charset="-120"/>
               </a:rPr>
-              <a:t>Sacrifice varieties — dravya, tapo, jñāna, svādhyāya</a:t>
+              <a:t>Sacrifice varieties â€” dravya, tapo, jÃ±Äna, svÄdhyÄya</a:t>
             </a:r>
             <a:endParaRPr lang="en-US" sz="1100" dirty="0"/>
           </a:p>
@@ -16833,7 +16833,7 @@
                 <a:ea typeface="Tiro Devanagari Sanskrit" pitchFamily="34" charset="-122"/>
                 <a:cs typeface="Tiro Devanagari Sanskrit" pitchFamily="34" charset="-120"/>
               </a:rPr>
-              <a:t>प्रतीक</a:t>
+              <a:t>à¤ªà¥à¤°à¤¤à¥€à¤•</a:t>
             </a:r>
             <a:endParaRPr lang="en-US" sz="1300" dirty="0"/>
           </a:p>
@@ -16872,7 +16872,7 @@
                 <a:ea typeface="Cormorant Garamond" pitchFamily="34" charset="-122"/>
                 <a:cs typeface="Cormorant Garamond" pitchFamily="34" charset="-120"/>
               </a:rPr>
-              <a:t>Symbols &amp; metaphors — aśvattha, ratha, praṇava</a:t>
+              <a:t>Symbols &amp; metaphors â€” aÅ›vattha, ratha, praá¹‡ava</a:t>
             </a:r>
             <a:endParaRPr lang="en-US" sz="1100" dirty="0"/>
           </a:p>
@@ -16982,7 +16982,7 @@
                 <a:ea typeface="Tiro Devanagari Sanskrit" pitchFamily="34" charset="-122"/>
                 <a:cs typeface="Tiro Devanagari Sanskrit" pitchFamily="34" charset="-120"/>
               </a:rPr>
-              <a:t>परमार्थ</a:t>
+              <a:t>à¤ªà¤°à¤®à¤¾à¤°à¥à¤¥</a:t>
             </a:r>
             <a:endParaRPr lang="en-US" sz="3000" dirty="0"/>
           </a:p>
@@ -17113,7 +17113,7 @@
                 <a:ea typeface="Tiro Devanagari Sanskrit" pitchFamily="34" charset="-122"/>
                 <a:cs typeface="Tiro Devanagari Sanskrit" pitchFamily="34" charset="-120"/>
               </a:rPr>
-              <a:t>ब्रह्म — परतत्त्व</a:t>
+              <a:t>à¤¬à¥à¤°à¤¹à¥à¤® â€” à¤ªà¤°à¤¤à¤¤à¥à¤¤à¥à¤µ</a:t>
             </a:r>
             <a:endParaRPr lang="en-US" sz="1300" dirty="0"/>
           </a:p>
@@ -17152,7 +17152,7 @@
                 <a:ea typeface="Cormorant Garamond" pitchFamily="34" charset="-122"/>
                 <a:cs typeface="Cormorant Garamond" pitchFamily="34" charset="-120"/>
               </a:rPr>
-              <a:t>BG 8.3 · 14.27 · 15.18</a:t>
+              <a:t>BG 8.3 Â· 14.27 Â· 15.18</a:t>
             </a:r>
             <a:endParaRPr lang="en-US" sz="950" dirty="0"/>
           </a:p>
@@ -17194,7 +17194,7 @@
                 <a:ea typeface="Tiro Devanagari Sanskrit" pitchFamily="34" charset="-122"/>
                 <a:cs typeface="Tiro Devanagari Sanskrit" pitchFamily="34" charset="-120"/>
               </a:rPr>
-              <a:t>मध्व-सिद्धान्ते ब्रह्म इति शब्दः केवलं विष्णोः (नारायणस्य) वाचकः — सर्वोत्तमः, क्षराक्षरातीतः पुरुषोत्तमः। न तु निर्विशेष-निरुपाधि-सामान्य-तत्त्ववाचकः।</a:t>
+              <a:t>à¤®à¤§à¥à¤µ-à¤¸à¤¿à¤¦à¥à¤§à¤¾à¤¨à¥à¤¤à¥‡ à¤¬à¥à¤°à¤¹à¥à¤® à¤‡à¤¤à¤¿ à¤¶à¤¬à¥à¤¦à¤ƒ à¤•à¥‡à¤µà¤²à¤‚ à¤µà¤¿à¤·à¥à¤£à¥‹à¤ƒ (à¤¨à¤¾à¤°à¤¾à¤¯à¤£à¤¸à¥à¤¯) à¤µà¤¾à¤šà¤•à¤ƒ â€” à¤¸à¤°à¥à¤µà¥‹à¤¤à¥à¤¤à¤®à¤ƒ, à¤•à¥à¤·à¤°à¤¾à¤•à¥à¤·à¤°à¤¾à¤¤à¥€à¤¤à¤ƒ à¤ªà¥…</a:t>
             </a:r>
             <a:endParaRPr lang="en-US" sz="1050" dirty="0"/>
           </a:p>
@@ -17283,7 +17283,7 @@
                 <a:ea typeface="Tiro Devanagari Sanskrit" pitchFamily="34" charset="-122"/>
                 <a:cs typeface="Tiro Devanagari Sanskrit" pitchFamily="34" charset="-120"/>
               </a:rPr>
-              <a:t>परमात्मा — अन्तर्यामी</a:t>
+              <a:t>à¤ªà¤°à¤®à¤¾à¤¤à¥à¤®à¤¾ â€” à¤…à¤¨à¥à¤¤à¤°à¥à¤¯à¤¾à¤®à¥€</a:t>
             </a:r>
             <a:endParaRPr lang="en-US" sz="1300" dirty="0"/>
           </a:p>
@@ -17322,7 +17322,7 @@
                 <a:ea typeface="Cormorant Garamond" pitchFamily="34" charset="-122"/>
                 <a:cs typeface="Cormorant Garamond" pitchFamily="34" charset="-120"/>
               </a:rPr>
-              <a:t>BG 13.22 · 15.17</a:t>
+              <a:t>BG 13.22 Â· 15.17</a:t>
             </a:r>
             <a:endParaRPr lang="en-US" sz="950" dirty="0"/>
           </a:p>
@@ -17364,7 +17364,7 @@
                 <a:ea typeface="Tiro Devanagari Sanskrit" pitchFamily="34" charset="-122"/>
                 <a:cs typeface="Tiro Devanagari Sanskrit" pitchFamily="34" charset="-120"/>
               </a:rPr>
-              <a:t>सर्वदेहेषु साक्षि-भर्ता-नियन्तृ-रूपेण स्थितः परम आत्मा। जीवात् अत्यन्तं भिन्नः (गी॰ १५।१७)।</a:t>
+              <a:t>à¤¸à¤°à¥à¤µà¤¦à¥‡à¤¹à¥‡à¤·à¥ à¤¸à¤¾à¤•à¥à¤·à¤¿-à¤­à¤°à¥à¤¤à¤¾-à¤¨à¤¿à¤¯à¤¨à¥à¤¤à¥ƒ-à¤°à¥‚à¤ªà¥‡à¤£ à¤¸à¥à¤¥à¤¿à¤¤à¤ƒ à¤ªà¤°à¤® à¤†à¤¤à¥à¤®à¤¾à¥¤ à¤œà¥€à¤µà¤¾à¤¤à¥ à¤…à¤¤à¥à¤¯à¤¨à¥à¤¤à¤‚ à¤­à¤¿à¤¨à¥à¤¨à¤ƒ (à¤—à¥€à¥° à¥§à¥«à¥¤à¥§à¥­)à¥¤</a:t>
             </a:r>
             <a:endParaRPr lang="en-US" sz="1050" dirty="0"/>
           </a:p>
@@ -17453,7 +17453,7 @@
                 <a:ea typeface="Tiro Devanagari Sanskrit" pitchFamily="34" charset="-122"/>
                 <a:cs typeface="Tiro Devanagari Sanskrit" pitchFamily="34" charset="-120"/>
               </a:rPr>
-              <a:t>पुरुषोत्तम — परमः पुरुषः</a:t>
+              <a:t>à¤ªà¥à¤°à¥à¤·à¥‹à¤¤à¥à¤¤à¤® â€” à¤ªà¤°à¤®à¤ƒ à¤ªà¥à¤°à¥à¤·à¤ƒ</a:t>
             </a:r>
             <a:endParaRPr lang="en-US" sz="1300" dirty="0"/>
           </a:p>
@@ -17492,7 +17492,7 @@
                 <a:ea typeface="Cormorant Garamond" pitchFamily="34" charset="-122"/>
                 <a:cs typeface="Cormorant Garamond" pitchFamily="34" charset="-120"/>
               </a:rPr>
-              <a:t>BG 15.18–19</a:t>
+              <a:t>BG 15.18â€“19</a:t>
             </a:r>
             <a:endParaRPr lang="en-US" sz="950" dirty="0"/>
           </a:p>
@@ -17534,7 +17534,7 @@
                 <a:ea typeface="Tiro Devanagari Sanskrit" pitchFamily="34" charset="-122"/>
                 <a:cs typeface="Tiro Devanagari Sanskrit" pitchFamily="34" charset="-120"/>
               </a:rPr>
-              <a:t>क्षराक्षरयोः अतीतः उत्तमः पुरुषः इति कृष्णस्य आत्म-निरूपणम्। पञ्चदशाध्यायस्य हर्मेन्यूतिक-केन्द्रम्।</a:t>
+              <a:t>à¤•à¥à¤·à¤°à¤¾à¤•à¥à¤·à¤°à¤¯à¥‹à¤ƒ à¤…à¤¤à¥€à¤¤à¤ƒ à¤‰à¤¤à¥à¤¤à¤®à¤ƒ à¤ªà¥à¤°à¥à¤·à¤ƒ à¤‡à¤¤à¤¿ à¤•à¥ƒà¤·à¥à¤£à¤¸à¥à¤¯ à¤†à¤¤à¥à¤®-à¤¨à¤¿à¤°à¥‚à¤ªà¤£à¤®à¥à¥¤ à¤ªà¤žà¥à¤šà¤¦à¤¶à¤¾à¤§à¥à¤¯à¤¾à¤¯à¤¸à¥à¤¯ à¤¹à¤°à¥à¤®à¥‡à¤¨à¥à¤¯à¥‚à¤¤à¤¿à¤•-à¤•à¥‡à¤…</a:t>
             </a:r>
             <a:endParaRPr lang="en-US" sz="1050" dirty="0"/>
           </a:p>
@@ -17623,7 +17623,7 @@
                 <a:ea typeface="Tiro Devanagari Sanskrit" pitchFamily="34" charset="-122"/>
                 <a:cs typeface="Tiro Devanagari Sanskrit" pitchFamily="34" charset="-120"/>
               </a:rPr>
-              <a:t>अक्षरपुरुषः — कूटस्थः</a:t>
+              <a:t>à¤…à¤•à¥à¤·à¤°à¤ªà¥à¤°à¥à¤·à¤ƒ â€” à¤•à¥‚à¤Ÿà¤¸à¥à¤¥à¤ƒ</a:t>
             </a:r>
             <a:endParaRPr lang="en-US" sz="1300" dirty="0"/>
           </a:p>
@@ -17704,7 +17704,7 @@
                 <a:ea typeface="Tiro Devanagari Sanskrit" pitchFamily="34" charset="-122"/>
                 <a:cs typeface="Tiro Devanagari Sanskrit" pitchFamily="34" charset="-120"/>
               </a:rPr>
-              <a:t>कूटस्थः अक्षरः — मध्व-मते लक्ष्मीः, नित्य-मुक्त-जीव-गण-मुख्या। हरेः अनन्तरं सर्वोत्तमा।</a:t>
+              <a:t>à¤•à¥‚à¤Ÿà¤¸à¥à¤¥à¤ƒ à¤…à¤•à¥à¤·à¤°à¤ƒ â€” à¤®à¤§à¥à¤µ-à¤®à¤¤à¥‡ à¤²à¤•à¥à¤·à¥à¤®à¥€à¤ƒ, à¤¨à¤¿à¤¤à¥à¤¯-à¤®à¥à¤•à¥à¤¤-à¤œà¥€à¤µ-à¤—à¤£-à¤®à¥à¤–à¥à¤¯à¤¾à¥¤ à¤¹à¤°à¥‡à¤ƒ à¤…à¤¨à¤¨à¥à¤¤à¤°à¤‚ à¤¸à¤°à¥à¤µà¥‹à¤¤à¥à¤¤à¤®à¤¾à¥¤</a:t>
             </a:r>
             <a:endParaRPr lang="en-US" sz="1050" dirty="0"/>
           </a:p>
@@ -17814,7 +17814,7 @@
                 <a:ea typeface="Tiro Devanagari Sanskrit" pitchFamily="34" charset="-122"/>
                 <a:cs typeface="Tiro Devanagari Sanskrit" pitchFamily="34" charset="-120"/>
               </a:rPr>
-              <a:t>तत्त्व</a:t>
+              <a:t>à¤¤à¤¤à¥à¤¤à¥à¤µ</a:t>
             </a:r>
             <a:endParaRPr lang="en-US" sz="3000" dirty="0"/>
           </a:p>
@@ -17945,7 +17945,7 @@
                 <a:ea typeface="Tiro Devanagari Sanskrit" pitchFamily="34" charset="-122"/>
                 <a:cs typeface="Tiro Devanagari Sanskrit" pitchFamily="34" charset="-120"/>
               </a:rPr>
-              <a:t>जीवः — देहस्थः आत्मा</a:t>
+              <a:t>à¤œà¥€à¤µà¤ƒ â€” à¤¦à¥‡à¤¹à¤¸à¥à¤¥à¤ƒ à¤†à¤¤à¥à¤®à¤¾</a:t>
             </a:r>
             <a:endParaRPr lang="en-US" sz="1300" dirty="0"/>
           </a:p>
@@ -18026,7 +18026,7 @@
                 <a:ea typeface="Tiro Devanagari Sanskrit" pitchFamily="34" charset="-122"/>
                 <a:cs typeface="Tiro Devanagari Sanskrit" pitchFamily="34" charset="-120"/>
               </a:rPr>
-              <a:t>हरेः नित्यः अंशः (गी॰ १५।७) — सत्यः, भिन्नः, बहुविधः, कदापि ब्रह्मणि लीनं न प्राप्नोति। मुक्ति-पर्यन्तम् अविद्यया बद्धः।</a:t>
+              <a:t>à¤¹à¤°à¥‡à¤ƒ à¤¨à¤¿à¤¤à¥à¤¯à¤ƒ à¤…à¤‚à¤¶à¤ƒ (à¤—à¥€à¥° à¥§à¥«à¥¤à¥­) â€” à¤¸à¤¤à¥à¤¯à¤ƒ, à¤­à¤¿à¤¨à¥à¤¨à¤ƒ, à¤¬à¤¹à¥à¤µà¤¿à¤§à¤ƒ, à¤•à¤¦à¤¾à¤ªà¤¿ à¤¬à¥à¤°à¤¹à¥à¤®à¤£à¤¿ à¤²à¥€à¤¨à¤‚ à¤¨ à¤ªà¥à¤°à¤¾à¤ªà¥à¤¨à¥‹à¤¤à¤¿à¥¤ à¤®à¥à¤•à¥à¤¤à¤¿-à¤ªà¤°à¥à¤¯à…</a:t>
             </a:r>
             <a:endParaRPr lang="en-US" sz="1050" dirty="0"/>
           </a:p>
@@ -18115,7 +18115,7 @@
                 <a:ea typeface="Tiro Devanagari Sanskrit" pitchFamily="34" charset="-122"/>
                 <a:cs typeface="Tiro Devanagari Sanskrit" pitchFamily="34" charset="-120"/>
               </a:rPr>
-              <a:t>प्रकृतिः — मूल-जडम्</a:t>
+              <a:t>à¤ªà¥à¤°à¤•à¥ƒà¤¤à¤¿à¤ƒ â€” à¤®à¥‚à¤²-à¤œà¤¡à¤®à¥</a:t>
             </a:r>
             <a:endParaRPr lang="en-US" sz="1300" dirty="0"/>
           </a:p>
@@ -18154,7 +18154,7 @@
                 <a:ea typeface="Cormorant Garamond" pitchFamily="34" charset="-122"/>
                 <a:cs typeface="Cormorant Garamond" pitchFamily="34" charset="-120"/>
               </a:rPr>
-              <a:t>BG 7.4–5 · 9.10</a:t>
+              <a:t>BG 7.4â€“5 Â· 9.10</a:t>
             </a:r>
             <a:endParaRPr lang="en-US" sz="950" dirty="0"/>
           </a:p>
@@ -18196,7 +18196,7 @@
                 <a:ea typeface="Tiro Devanagari Sanskrit" pitchFamily="34" charset="-122"/>
                 <a:cs typeface="Tiro Devanagari Sanskrit" pitchFamily="34" charset="-120"/>
               </a:rPr>
-              <a:t>हरेः अपरा-प्रकृतिः अष्टधा — भूमि, आपः, अनलः, वायुः, खम्, मनः, बुद्धिः, अहङ्कारः। सर्व-रूप-योनिः।</a:t>
+              <a:t>à¤¹à¤°à¥‡à¤ƒ à¤…à¤ªà¤°à¤¾-à¤ªà¥à¤°à¤•à¥ƒà¤¤à¤¿à¤ƒ à¤…à¤·à¥à¤Ÿà¤§à¤¾ â€” à¤­à¥‚à¤®à¤¿, à¤†à¤ªà¤ƒ, à¤…à¤¨à¤²à¤ƒ, à¤µà¤¾à¤¯à¥à¤ƒ, à¤–à¤®à¥, à¤®à¤¨à¤ƒ, à¤¬à¥à¤¦à¥à¤§à¤¿à¤ƒ, à¤…à¤¹à¤™à¥à¤•à¤¾à¤°à¤ƒà¥¤ à¤¸à¤°à¥à¤µ-à¤°à¥‚à¤ª-à¤¯à¥‹à¤¨à¤¿à¤ƒà¥¤</a:t>
             </a:r>
             <a:endParaRPr lang="en-US" sz="1050" dirty="0"/>
           </a:p>
@@ -18285,7 +18285,7 @@
                 <a:ea typeface="Tiro Devanagari Sanskrit" pitchFamily="34" charset="-122"/>
                 <a:cs typeface="Tiro Devanagari Sanskrit" pitchFamily="34" charset="-120"/>
               </a:rPr>
-              <a:t>स्वभावः — सहज-प्रकृतिः</a:t>
+              <a:t>à¤¸à¥à¤µà¤­à¤¾à¤µà¤ƒ â€” à¤¸à¤¹à¤œ-à¤ªà¥à¤°à¤•à¥ƒà¤¤à¤¿à¤ƒ</a:t>
             </a:r>
             <a:endParaRPr lang="en-US" sz="1300" dirty="0"/>
           </a:p>
@@ -18324,7 +18324,7 @@
                 <a:ea typeface="Cormorant Garamond" pitchFamily="34" charset="-122"/>
                 <a:cs typeface="Cormorant Garamond" pitchFamily="34" charset="-120"/>
               </a:rPr>
-              <a:t>BG 5.14 · 8.3 · 18.41</a:t>
+              <a:t>BG 5.14 Â· 8.3 Â· 18.41</a:t>
             </a:r>
             <a:endParaRPr lang="en-US" sz="950" dirty="0"/>
           </a:p>
@@ -18366,7 +18366,7 @@
                 <a:ea typeface="Tiro Devanagari Sanskrit" pitchFamily="34" charset="-122"/>
                 <a:cs typeface="Tiro Devanagari Sanskrit" pitchFamily="34" charset="-120"/>
               </a:rPr>
-              <a:t>प्रत्येक-जीवस्य अनादिः सहजः स्वभावः (मध्व-मते स्वरूप-योग्यता)। वर्णं सामर्थ्यं अन्तिम-गतिं च निर्धारयति।</a:t>
+              <a:t>à¤ªà¥à¤°à¤¤à¥à¤¯à¥‡à¤•-à¤œà¥€à¤µà¤¸à¥à¤¯ à¤…à¤¨à¤¾à¤¦à¤¿à¤ƒ à¤¸à¤¹à¤œà¤ƒ à¤¸à¥à¤µà¤­à¤¾à¤µà¤ƒ (à¤®à¤§à¥à¤µ-à¤®à¤¤à¥‡ à¤¸à¥à¤µà¤°à¥‚à¤ª-à¤¯à¥‹à¤—à¥à¤¯à¤¤à¤¾)à¥¤ à¤µà¤°à¥à¤£à¤‚ à¤¸à¤¾à¤®à¤°à¥à¤¥à¥à¤¯à¤‚ à¤…à¤¨à¥à¤¤à¤¿à¤®-à¤—à¤¤à¤¿à¤‚ à¤š à¤¨à¤¿à¤°à¥…</a:t>
             </a:r>
             <a:endParaRPr lang="en-US" sz="1050" dirty="0"/>
           </a:p>
@@ -18455,7 +18455,7 @@
                 <a:ea typeface="Tiro Devanagari Sanskrit" pitchFamily="34" charset="-122"/>
                 <a:cs typeface="Tiro Devanagari Sanskrit" pitchFamily="34" charset="-120"/>
               </a:rPr>
-              <a:t>ईश्वरः — नियन्ता</a:t>
+              <a:t>à¤ˆà¤¶à¥à¤µà¤°à¤ƒ â€” à¤¨à¤¿à¤¯à¤¨à¥à¤¤à¤¾</a:t>
             </a:r>
             <a:endParaRPr lang="en-US" sz="1300" dirty="0"/>
           </a:p>
@@ -18536,7 +18536,7 @@
                 <a:ea typeface="Tiro Devanagari Sanskrit" pitchFamily="34" charset="-122"/>
                 <a:cs typeface="Tiro Devanagari Sanskrit" pitchFamily="34" charset="-120"/>
               </a:rPr>
-              <a:t>हरिः अन्तर्यामि-रूपेण सर्व-हृदये तिष्ठन् यन्त्रारूढ-मायया जीवान् भ्रामयति।</a:t>
+              <a:t>à¤¹à¤°à¤¿à¤ƒ à¤…à¤¨à¥à¤¤à¤°à¥à¤¯à¤¾à¤®à¤¿-à¤°à¥‚à¤ªà¥‡à¤£ à¤¸à¤°à¥à¤µ-à¤¹à¥ƒà¤¦à¤¯à¥‡ à¤¤à¤¿à¤·à¥à¤ à¤¨à¥ à¤¯à¤¨à¥à¤¤à¥à¤°à¤¾à¤°à¥‚à¤¢-à¤®à¤¾à¤¯à¤¯à¤¾ à¤œà¥€à¤µà¤¾à¤¨à¥ à¤­à¥à¤°à¤¾à¤®à¤¯à¤¤à¤¿à¥¤</a:t>
             </a:r>
             <a:endParaRPr lang="en-US" sz="1050" dirty="0"/>
           </a:p>
@@ -18646,7 +18646,7 @@
                 <a:ea typeface="Tiro Devanagari Sanskrit" pitchFamily="34" charset="-122"/>
                 <a:cs typeface="Tiro Devanagari Sanskrit" pitchFamily="34" charset="-120"/>
               </a:rPr>
-              <a:t>क्षेत्र-क्षेत्रज्ञ</a:t>
+              <a:t>à¤•à¥à¤·à¥‡à¤¤à¥à¤°-à¤•à¥à¤·à¥‡à¤¤à¥à¤°à¤œà¥à¤ž</a:t>
             </a:r>
             <a:endParaRPr lang="en-US" sz="3000" dirty="0"/>
           </a:p>
@@ -18777,7 +18777,7 @@
                 <a:ea typeface="Tiro Devanagari Sanskrit" pitchFamily="34" charset="-122"/>
                 <a:cs typeface="Tiro Devanagari Sanskrit" pitchFamily="34" charset="-120"/>
               </a:rPr>
-              <a:t>क्षेत्रज्ञः — क्षेत्र-वेत्ता</a:t>
+              <a:t>à¤•à¥à¤·à¥‡à¤¤à¥à¤°à¤œà¥à¤žà¤ƒ â€” à¤•à¥à¤·à¥‡à¤¤à¥à¤°-à¤µà¥‡à¤¤à¥à¤¤à¤¾</a:t>
             </a:r>
             <a:endParaRPr lang="en-US" sz="1300" dirty="0"/>
           </a:p>
@@ -18858,7 +18858,7 @@
                 <a:ea typeface="Tiro Devanagari Sanskrit" pitchFamily="34" charset="-122"/>
                 <a:cs typeface="Tiro Devanagari Sanskrit" pitchFamily="34" charset="-120"/>
               </a:rPr>
-              <a:t>क्षेत्रं वेत्ति यः सः क्षेत्रज्ञः। कृष्ण-वचनम् — "क्षेत्रज्ञं चापि मां विद्धि सर्व-क्षेत्रेषु भारत" — हरिः परमः क्षेत्रज्ञः।</a:t>
+              <a:t>à¤•à¥à¤·à¥‡à¤¤à¥à¤°à¤‚ à¤µà¥‡à¤¤à¥à¤¤à¤¿ à¤¯à¤ƒ à¤¸à¤ƒ à¤•à¥à¤·à¥‡à¤¤à¥à¤°à¤œà¥à¤žà¤ƒà¥¤ à¤•à¥ƒà¤·à¥à¤£-à¤µà¤šà¤¨à¤®à¥ â€” "à¤•à¥à¤·à¥‡à¤¤à¥à¤°à¤œà¥à¤žà¤‚ à¤šà¤¾à¤ªà¤¿ à¤®à¤¾à¤‚ à¤µà¤¿à¤¦à¥à¤§à¤¿ à¤¸à¤°à¥à¤µ-à¤•à¥à¤·à¥‡à¤¤à¥à¤°à¥‡à¤·à¥ à¤­à¤¾…</a:t>
             </a:r>
             <a:endParaRPr lang="en-US" sz="1050" dirty="0"/>
           </a:p>
@@ -18947,7 +18947,7 @@
                 <a:ea typeface="Tiro Devanagari Sanskrit" pitchFamily="34" charset="-122"/>
                 <a:cs typeface="Tiro Devanagari Sanskrit" pitchFamily="34" charset="-120"/>
               </a:rPr>
-              <a:t>क्षेत्रम् — शरीरम्</a:t>
+              <a:t>à¤•à¥à¤·à¥‡à¤¤à¥à¤°à¤®à¥ â€” à¤¶à¤°à¥€à¤°à¤®à¥</a:t>
             </a:r>
             <a:endParaRPr lang="en-US" sz="1300" dirty="0"/>
           </a:p>
@@ -18986,7 +18986,7 @@
                 <a:ea typeface="Cormorant Garamond" pitchFamily="34" charset="-122"/>
                 <a:cs typeface="Cormorant Garamond" pitchFamily="34" charset="-120"/>
               </a:rPr>
-              <a:t>BG 13.1 · 13.5–6</a:t>
+              <a:t>BG 13.1 Â· 13.5â€“6</a:t>
             </a:r>
             <a:endParaRPr lang="en-US" sz="950" dirty="0"/>
           </a:p>
@@ -19028,7 +19028,7 @@
                 <a:ea typeface="Tiro Devanagari Sanskrit" pitchFamily="34" charset="-122"/>
                 <a:cs typeface="Tiro Devanagari Sanskrit" pitchFamily="34" charset="-120"/>
               </a:rPr>
-              <a:t>इदं शरीरं चतुर्विंशति-तत्त्व-संघातः — महाभूतानि, अहङ्कारः, बुद्धिः, अव्यक्तम्, इन्द्रियाणि, मनः, विषयाः, इच्छा, द्वेषः, सुखं, दुःखं, सङ्घातः, चेतना, धृतिः।</a:t>
+              <a:t>à¤‡à¤¦à¤‚ à¤¶à¤°à¥€à¤°à¤‚ à¤šà¤¤à¥à¤°à¥à¤µà¤¿à¤‚à¤¶à¤¤à¤¿-à¤¤à¤¤à¥à¤¤à¥à¤µ-à¤¸à¤‚à¤˜à¤¾à¤¤à¤ƒ â€” à¤®à¤¹à¤¾à¤­à¥‚à¤¤à¤¾à¤¨à¤¿, à¤…à¤¹à¤™à¥à¤•à¤¾à¤°à¤ƒ, à¤¬à¥à¤¦à¥à¤§à¤¿à¤ƒ, à¤…à¤µà¥à¤¯à¤•à¥à¤¤à¤®à¥, à¤‡à¤¨à¥à¤¦à¥à¤°à¤¿à¤¯à¤¾à¤£à¤¿, à¤®à¤¨à¤ƒ, à¤µ…</a:t>
             </a:r>
             <a:endParaRPr lang="en-US" sz="1050" dirty="0"/>
           </a:p>
@@ -19117,7 +19117,7 @@
                 <a:ea typeface="Tiro Devanagari Sanskrit" pitchFamily="34" charset="-122"/>
                 <a:cs typeface="Tiro Devanagari Sanskrit" pitchFamily="34" charset="-120"/>
               </a:rPr>
-              <a:t>महाभूतानि — पञ्च-स्थूल-तत्त्वानि</a:t>
+              <a:t>à¤®à¤¹à¤¾à¤­à¥‚à¤¤à¤¾à¤¨à¤¿ â€” à¤ªà¤žà¥à¤š-à¤¸à¥à¤¥à¥‚à¤²-à¤¤à¤¤à¥à¤¤à¥à¤µà¤¾à¤¨à¤¿</a:t>
             </a:r>
             <a:endParaRPr lang="en-US" sz="1300" dirty="0"/>
           </a:p>
@@ -19198,7 +19198,7 @@
                 <a:ea typeface="Tiro Devanagari Sanskrit" pitchFamily="34" charset="-122"/>
                 <a:cs typeface="Tiro Devanagari Sanskrit" pitchFamily="34" charset="-120"/>
               </a:rPr>
-              <a:t>पृथिवी, अप्, तेजः, वायुः, आकाशः — चतुर्विंशति-क्षेत्र-तत्त्वेषु प्रथमानि पञ्च।</a:t>
+              <a:t>à¤ªà¥ƒà¤¥à¤¿à¤µà¥€, à¤…à¤ªà¥, à¤¤à¥‡à¤œà¤ƒ, à¤µà¤¾à¤¯à¥à¤ƒ, à¤†à¤•à¤¾à¤¶à¤ƒ â€” à¤šà¤¤à¥à¤°à¥à¤µà¤¿à¤‚à¤¶à¤¤à¤¿-à¤•à¥à¤·à¥‡à¤¤à¥à¤°-à¤¤à¤¤à¥à¤¤à¥à¤µà¥‡à¤·à¥ à¤ªà¥à¤°à¤¥à¤®à¤¾à¤¨à¤¿ à¤ªà¤žà¥à¤šà¥¤</a:t>
             </a:r>
             <a:endParaRPr lang="en-US" sz="1050" dirty="0"/>
           </a:p>
@@ -19287,7 +19287,7 @@
                 <a:ea typeface="Tiro Devanagari Sanskrit" pitchFamily="34" charset="-122"/>
                 <a:cs typeface="Tiro Devanagari Sanskrit" pitchFamily="34" charset="-120"/>
               </a:rPr>
-              <a:t>अव्यक्तम् — मूल-प्रकृतिः</a:t>
+              <a:t>à¤…à¤µà¥à¤¯à¤•à¥à¤¤à¤®à¥ â€” à¤®à¥‚à¤²-à¤ªà¥à¤°à¤•à¥ƒà¤¤à¤¿à¤ƒ</a:t>
             </a:r>
             <a:endParaRPr lang="en-US" sz="1300" dirty="0"/>
           </a:p>
@@ -19326,7 +19326,7 @@
                 <a:ea typeface="Cormorant Garamond" pitchFamily="34" charset="-122"/>
                 <a:cs typeface="Cormorant Garamond" pitchFamily="34" charset="-120"/>
               </a:rPr>
-              <a:t>BG 13.5 · 8.18</a:t>
+              <a:t>BG 13.5 Â· 8.18</a:t>
             </a:r>
             <a:endParaRPr lang="en-US" sz="950" dirty="0"/>
           </a:p>
@@ -19368,7 +19368,7 @@
                 <a:ea typeface="Tiro Devanagari Sanskrit" pitchFamily="34" charset="-122"/>
                 <a:cs typeface="Tiro Devanagari Sanskrit" pitchFamily="34" charset="-120"/>
               </a:rPr>
-              <a:t>विकार-पूर्ववर्ती मूल-प्रकृतिः। ततः महान्, अहङ्कारः, तन्मात्राणि च प्रवर्तन्ते।</a:t>
+              <a:t>à¤µà¤¿à¤•à¤¾à¤°-à¤ªà¥‚à¤°à¥à¤µà¤µà¤°à¥à¤¤à¥€ à¤®à¥‚à¤²-à¤ªà¥à¤°à¤•à¥ƒà¤¤à¤¿à¤ƒà¥¤ à¤¤à¤¤à¤ƒ à¤®à¤¹à¤¾à¤¨à¥, à¤…à¤¹à¤™à¥à¤•à¤¾à¤°à¤ƒ, à¤¤à¤¨à¥à¤®à¤¾à¤¤à¥à¤°à¤¾à¤£à¤¿ à¤š à¤ªà¥à¤°à¤µà¤°à¥à¤¤à¤¨à¥à¤¤à¥‡à¥¤</a:t>
             </a:r>
             <a:endParaRPr lang="en-US" sz="1050" dirty="0"/>
           </a:p>
@@ -19478,7 +19478,7 @@
                 <a:ea typeface="Tiro Devanagari Sanskrit" pitchFamily="34" charset="-122"/>
                 <a:cs typeface="Tiro Devanagari Sanskrit" pitchFamily="34" charset="-120"/>
               </a:rPr>
-              <a:t>गुण</a:t>
+              <a:t>à¤—à¥à¤£</a:t>
             </a:r>
             <a:endParaRPr lang="en-US" sz="3000" dirty="0"/>
           </a:p>
@@ -19609,7 +19609,7 @@
                 <a:ea typeface="Tiro Devanagari Sanskrit" pitchFamily="34" charset="-122"/>
                 <a:cs typeface="Tiro Devanagari Sanskrit" pitchFamily="34" charset="-120"/>
               </a:rPr>
-              <a:t>प्रकाशस्य गुणः</a:t>
+              <a:t>à¤ªà¥à¤°à¤•à¤¾à¤¶à¤¸à¥à¤¯ à¤—à¥à¤£à¤ƒ</a:t>
             </a:r>
             <a:endParaRPr lang="en-US" sz="1300" dirty="0"/>
           </a:p>
@@ -19648,7 +19648,7 @@
                 <a:ea typeface="Cormorant Garamond" pitchFamily="34" charset="-122"/>
                 <a:cs typeface="Cormorant Garamond" pitchFamily="34" charset="-120"/>
               </a:rPr>
-              <a:t>BG 14.6 · 14.11</a:t>
+              <a:t>BG 14.6 Â· 14.11</a:t>
             </a:r>
             <a:endParaRPr lang="en-US" sz="950" dirty="0"/>
           </a:p>
@@ -19690,7 +19690,7 @@
                 <a:ea typeface="Tiro Devanagari Sanskrit" pitchFamily="34" charset="-122"/>
                 <a:cs typeface="Tiro Devanagari Sanskrit" pitchFamily="34" charset="-120"/>
               </a:rPr>
-              <a:t>लघु, प्रकाशकम्, अनामयम् — सुखसङ्गेन ज्ञानसङ्गेन च जीवं बध्नाति। विवेकिषु प्रबलः।</a:t>
+              <a:t>à¤²à¤˜à¥, à¤ªà¥à¤°à¤•à¤¾à¤¶à¤•à¤®à¥, à¤…à¤¨à¤¾à¤®à¤¯à¤®à¥ â€” à¤¸à¥à¤–à¤¸à¤™à¥à¤—à¥‡à¤¨ à¤œà¥à¤žà¤¾à¤¨à¤¸à¤™à¥à¤—à¥‡à¤¨ à¤š à¤œà¥€à¤µà¤‚ à¤¬à¤§à¥à¤¨à¤¾à¤¤à¤¿à¥¤ à¤µà¤¿à¤µà¥‡à¤•à¤¿à¤·à¥ à¤ªà¥à¤°à¤¬à¤²à¤ƒà¥¤</a:t>
             </a:r>
             <a:endParaRPr lang="en-US" sz="1050" dirty="0"/>
           </a:p>
@@ -19779,7 +19779,7 @@
                 <a:ea typeface="Tiro Devanagari Sanskrit" pitchFamily="34" charset="-122"/>
                 <a:cs typeface="Tiro Devanagari Sanskrit" pitchFamily="34" charset="-120"/>
               </a:rPr>
-              <a:t>रागस्य गुणः</a:t>
+              <a:t>à¤°à¤¾à¤—à¤¸à¥à¤¯ à¤—à¥à¤£à¤ƒ</a:t>
             </a:r>
             <a:endParaRPr lang="en-US" sz="1300" dirty="0"/>
           </a:p>
@@ -19818,7 +19818,7 @@
                 <a:ea typeface="Cormorant Garamond" pitchFamily="34" charset="-122"/>
                 <a:cs typeface="Cormorant Garamond" pitchFamily="34" charset="-120"/>
               </a:rPr>
-              <a:t>BG 14.7 · 14.12</a:t>
+              <a:t>BG 14.7 Â· 14.12</a:t>
             </a:r>
             <a:endParaRPr lang="en-US" sz="950" dirty="0"/>
           </a:p>
@@ -19860,7 +19860,7 @@
                 <a:ea typeface="Tiro Devanagari Sanskrit" pitchFamily="34" charset="-122"/>
                 <a:cs typeface="Tiro Devanagari Sanskrit" pitchFamily="34" charset="-120"/>
               </a:rPr>
-              <a:t>रागात्मकं सङ्गात्मकं — तृष्णासङ्गयोः समुद्भवम्। अनवरतकर्मप्रवर्तकम्।</a:t>
+              <a:t>à¤°à¤¾à¤—à¤¾à¤¤à¥à¤®à¤•à¤‚ à¤¸à¤™à¥à¤—à¤¾à¤¤à¥à¤®à¤•à¤‚ â€” à¤¤à¥ƒà¤·à¥à¤£à¤¾à¤¸à¤™à¥à¤—à¤¯à¥‹à¤ƒ à¤¸à¤®à¥à¤¦à¥à¤­à¤µà¤®à¥à¥¤ à¤…à¤¨à¤µà¤°à¤¤à¤•à¤°à¥à¤®à¤ªà¥à¤°à¤µà¤°à¥à¤¤à¤•à¤®à¥à¥¤</a:t>
             </a:r>
             <a:endParaRPr lang="en-US" sz="1050" dirty="0"/>
           </a:p>
@@ -19949,7 +19949,7 @@
                 <a:ea typeface="Tiro Devanagari Sanskrit" pitchFamily="34" charset="-122"/>
                 <a:cs typeface="Tiro Devanagari Sanskrit" pitchFamily="34" charset="-120"/>
               </a:rPr>
-              <a:t>अन्धकारस्य गुणः</a:t>
+              <a:t>à¤…à¤¨à¥à¤§à¤•à¤¾à¤°à¤¸à¥à¤¯ à¤—à¥à¤£à¤ƒ</a:t>
             </a:r>
             <a:endParaRPr lang="en-US" sz="1300" dirty="0"/>
           </a:p>
@@ -19988,7 +19988,7 @@
                 <a:ea typeface="Cormorant Garamond" pitchFamily="34" charset="-122"/>
                 <a:cs typeface="Cormorant Garamond" pitchFamily="34" charset="-120"/>
               </a:rPr>
-              <a:t>BG 14.8 · 14.13</a:t>
+              <a:t>BG 14.8 Â· 14.13</a:t>
             </a:r>
             <a:endParaRPr lang="en-US" sz="950" dirty="0"/>
           </a:p>
@@ -20030,7 +20030,7 @@
                 <a:ea typeface="Tiro Devanagari Sanskrit" pitchFamily="34" charset="-122"/>
                 <a:cs typeface="Tiro Devanagari Sanskrit" pitchFamily="34" charset="-120"/>
               </a:rPr>
-              <a:t>अज्ञानजं — सर्वान् देहिनो मोहयति; प्रमादालस्यनिद्राभिर्बध्नाति।</a:t>
+              <a:t>à¤…à¤œà¥à¤žà¤¾à¤¨à¤œà¤‚ â€” à¤¸à¤°à¥à¤µà¤¾à¤¨à¥ à¤¦à¥‡à¤¹à¤¿à¤¨à¥‹ à¤®à¥‹à¤¹à¤¯à¤¤à¤¿; à¤ªà¥à¤°à¤®à¤¾à¤¦à¤¾à¤²à¤¸à¥à¤¯à¤¨à¤¿à¤¦à¥à¤°à¤¾à¤­à¤¿à¤°à¥à¤¬à¤§à¥à¤¨à¤¾à¤¤à¤¿à¥¤</a:t>
             </a:r>
             <a:endParaRPr lang="en-US" sz="1050" dirty="0"/>
           </a:p>
@@ -20119,7 +20119,7 @@
                 <a:ea typeface="Tiro Devanagari Sanskrit" pitchFamily="34" charset="-122"/>
                 <a:cs typeface="Tiro Devanagari Sanskrit" pitchFamily="34" charset="-120"/>
               </a:rPr>
-              <a:t>गुणानामतीतः</a:t>
+              <a:t>à¤—à¥à¤£à¤¾à¤¨à¤¾à¤®à¤¤à¥€à¤¤à¤ƒ</a:t>
             </a:r>
             <a:endParaRPr lang="en-US" sz="1300" dirty="0"/>
           </a:p>
@@ -20158,7 +20158,7 @@
                 <a:ea typeface="Cormorant Garamond" pitchFamily="34" charset="-122"/>
                 <a:cs typeface="Cormorant Garamond" pitchFamily="34" charset="-120"/>
               </a:rPr>
-              <a:t>BG 14.22–25</a:t>
+              <a:t>BG 14.22â€“25</a:t>
             </a:r>
             <a:endParaRPr lang="en-US" sz="950" dirty="0"/>
           </a:p>
@@ -20200,7 +20200,7 @@
                 <a:ea typeface="Tiro Devanagari Sanskrit" pitchFamily="34" charset="-122"/>
                 <a:cs typeface="Tiro Devanagari Sanskrit" pitchFamily="34" charset="-120"/>
               </a:rPr>
-              <a:t>यस्मिन् सङ्गाद् गुणप्रवृत्तिर्न जायते; मित्रारिषु समः; सर्वारम्भपरित्यागी।</a:t>
+              <a:t>à¤¯à¤¸à¥à¤®à¤¿à¤¨à¥ à¤¸à¤™à¥à¤—à¤¾à¤¦à¥ à¤—à¥à¤£à¤ªà¥à¤°à¤µà¥ƒà¤¤à¥à¤¤à¤¿à¤°à¥à¤¨ à¤œà¤¾à¤¯à¤¤à¥‡; à¤®à¤¿à¤¤à¥à¤°à¤¾à¤°à¤¿à¤·à¥ à¤¸à¤®à¤ƒ; à¤¸à¤°à¥à¤µà¤¾à¤°à¤®à¥à¤­à¤ªà¤°à¤¿à¤¤à¥à¤¯à¤¾à¤—à¥€à¥¤</a:t>
             </a:r>
             <a:endParaRPr lang="en-US" sz="1050" dirty="0"/>
           </a:p>
@@ -20310,7 +20310,7 @@
                 <a:ea typeface="Tiro Devanagari Sanskrit" pitchFamily="34" charset="-122"/>
                 <a:cs typeface="Tiro Devanagari Sanskrit" pitchFamily="34" charset="-120"/>
               </a:rPr>
-              <a:t>योग</a:t>
+              <a:t>à¤¯à¥‹à¤—</a:t>
             </a:r>
             <a:endParaRPr lang="en-US" sz="3000" dirty="0"/>
           </a:p>
@@ -20441,7 +20441,7 @@
                 <a:ea typeface="Tiro Devanagari Sanskrit" pitchFamily="34" charset="-122"/>
                 <a:cs typeface="Tiro Devanagari Sanskrit" pitchFamily="34" charset="-120"/>
               </a:rPr>
-              <a:t>भक्तिमार्गः</a:t>
+              <a:t>à¤­à¤•à¥à¤¤à¤¿à¤®à¤¾à¤°à¥à¤—à¤ƒ</a:t>
             </a:r>
             <a:endParaRPr lang="en-US" sz="1300" dirty="0"/>
           </a:p>
@@ -20480,7 +20480,7 @@
                 <a:ea typeface="Cormorant Garamond" pitchFamily="34" charset="-122"/>
                 <a:cs typeface="Cormorant Garamond" pitchFamily="34" charset="-120"/>
               </a:rPr>
-              <a:t>BG 9.22 · 11.54 · 18.55</a:t>
+              <a:t>BG 9.22 Â· 11.54 Â· 18.55</a:t>
             </a:r>
             <a:endParaRPr lang="en-US" sz="950" dirty="0"/>
           </a:p>
@@ -20522,7 +20522,7 @@
                 <a:ea typeface="Tiro Devanagari Sanskrit" pitchFamily="34" charset="-122"/>
                 <a:cs typeface="Tiro Devanagari Sanskrit" pitchFamily="34" charset="-120"/>
               </a:rPr>
-              <a:t>हरौ प्रेमपूर्वकं ज्ञानं — सर्वज्ञानातिशायि। मध्वमते भक्तिः स्थिरज्ञानपूर्विकाप्रेमरूपा, मोक्षस्य अनिवार्यः हेतुः।</a:t>
+              <a:t>à¤¹à¤°à¥Œ à¤ªà¥à¤°à¥‡à¤®à¤ªà¥‚à¤°à¥à¤µà¤•à¤‚ à¤œà¥à¤žà¤¾à¤¨à¤‚ â€” à¤¸à¤°à¥à¤µà¤œà¥à¤žà¤¾à¤¨à¤¾à¤¤à¤¿à¤¶à¤¾à¤¯à¤¿à¥¤ à¤®à¤§à¥à¤µà¤®à¤¤à¥‡ à¤­à¤•à¥à¤¤à¤¿à¤ƒ à¤¸à¥à¤¥à¤¿à¤°à¤œà¥à¤žà¤¾à¤¨à¤ªà¥‚à¤°à¥à¤µà¤¿à¤•à¤¾à¤ªà¥à¤°à¥‡à¤®à¤°à¥‚à¤ªà¤¾, à¤®à¥‹à¤•à¥…</a:t>
             </a:r>
             <a:endParaRPr lang="en-US" sz="1050" dirty="0"/>
           </a:p>
@@ -20611,7 +20611,7 @@
                 <a:ea typeface="Tiro Devanagari Sanskrit" pitchFamily="34" charset="-122"/>
                 <a:cs typeface="Tiro Devanagari Sanskrit" pitchFamily="34" charset="-120"/>
               </a:rPr>
-              <a:t>हरौ शरणागतिः</a:t>
+              <a:t>à¤¹à¤°à¥Œ à¤¶à¤°à¤£à¤¾à¤—à¤¤à¤¿à¤ƒ</a:t>
             </a:r>
             <a:endParaRPr lang="en-US" sz="1300" dirty="0"/>
           </a:p>
@@ -20692,7 +20692,7 @@
                 <a:ea typeface="Tiro Devanagari Sanskrit" pitchFamily="34" charset="-122"/>
                 <a:cs typeface="Tiro Devanagari Sanskrit" pitchFamily="34" charset="-120"/>
               </a:rPr>
-              <a:t>'सर्वधर्मान् परित्यज्य मामेकं शरणं व्रज' — गीतायाः चरमोपदेशः। हरिं सर्वशरणं कृत्वा सर्वपापमोचनम्।</a:t>
+              <a:t>'à¤¸à¤°à¥à¤µà¤§à¤°à¥à¤®à¤¾à¤¨à¥ à¤ªà¤°à¤¿à¤¤à¥à¤¯à¤œà¥à¤¯ à¤®à¤¾à¤®à¥‡à¤•à¤‚ à¤¶à¤°à¤£à¤‚ à¤µà¥à¤°à¤œ' â€” à¤—à¥€à¤¤à¤¾à¤¯à¤¾à¤ƒ à¤šà¤°à¤®à¥‹à¤ªà¤¦à¥‡à¤¶à¤ƒà¥¤ à¤¹à¤°à¤¿à¤‚ à¤¸à¤°à¥à¤µà¤¶à¤°à¤£à¤‚ à¤•à¥ƒà¤¤à¥à¤µà¤¾ à¤¸à¤°à¥à¤µà¤ªà¤¾à¤ªà¤®à¥‹à¤šà¤¨à¤…</a:t>
             </a:r>
             <a:endParaRPr lang="en-US" sz="1050" dirty="0"/>
           </a:p>
@@ -20781,7 +20781,7 @@
                 <a:ea typeface="Tiro Devanagari Sanskrit" pitchFamily="34" charset="-122"/>
                 <a:cs typeface="Tiro Devanagari Sanskrit" pitchFamily="34" charset="-120"/>
               </a:rPr>
-              <a:t>निष्कामकर्मणो मार्गः</a:t>
+              <a:t>à¤¨à¤¿à¤·à¥à¤•à¤¾à¤®à¤•à¤°à¥à¤®à¤£à¥‹ à¤®à¤¾à¤°à¥à¤—à¤ƒ</a:t>
             </a:r>
             <a:endParaRPr lang="en-US" sz="1300" dirty="0"/>
           </a:p>
@@ -20820,7 +20820,7 @@
                 <a:ea typeface="Cormorant Garamond" pitchFamily="34" charset="-122"/>
                 <a:cs typeface="Cormorant Garamond" pitchFamily="34" charset="-120"/>
               </a:rPr>
-              <a:t>BG 3.3 · 3.19 · 5.2</a:t>
+              <a:t>BG 3.3 Â· 3.19 Â· 5.2</a:t>
             </a:r>
             <a:endParaRPr lang="en-US" sz="950" dirty="0"/>
           </a:p>
@@ -20862,7 +20862,7 @@
                 <a:ea typeface="Tiro Devanagari Sanskrit" pitchFamily="34" charset="-122"/>
                 <a:cs typeface="Tiro Devanagari Sanskrit" pitchFamily="34" charset="-120"/>
               </a:rPr>
-              <a:t>स्वकीयं कर्तव्यं हरये अर्पणं कृत्वा, सर्वफलं तस्मै समर्प्य आचरणम्। श्रीकृष्णस्य अर्जुनाय प्रमुखोपदेशः।</a:t>
+              <a:t>à¤¸à¥à¤µà¤•à¥€à¤¯à¤‚ à¤•à¤°à¥à¤¤à¤µà¥à¤¯à¤‚ à¤¹à¤°à¤¯à¥‡ à¤…à¤°à¥à¤ªà¤£à¤‚ à¤•à¥ƒà¤¤à¥à¤µà¤¾, à¤¸à¤°à¥à¤µà¤«à¤²à¤‚ à¤¤à¤¸à¥à¤®à¥ˆ à¤¸à¤®à¤°à¥à¤ªà¥à¤¯ à¤†à¤šà¤°à¤£à¤®à¥à¥¤ à¤¶à¥à¤°à¥€à¤•à¥ƒà¤·à¥à¤£à¤¸à¥à¤¯ à¤…à¤°à¥à¤œà¥à¤¨à¤¾à¤¯ à¤ªà¥à¤°à¤®à¥…</a:t>
             </a:r>
             <a:endParaRPr lang="en-US" sz="1050" dirty="0"/>
           </a:p>
@@ -20951,7 +20951,7 @@
                 <a:ea typeface="Tiro Devanagari Sanskrit" pitchFamily="34" charset="-122"/>
                 <a:cs typeface="Tiro Devanagari Sanskrit" pitchFamily="34" charset="-120"/>
               </a:rPr>
-              <a:t>विवेकज्ञानमार्गः</a:t>
+              <a:t>à¤µà¤¿à¤µà¥‡à¤•à¤œà¥à¤žà¤¾à¤¨à¤®à¤¾à¤°à¥à¤—à¤ƒ</a:t>
             </a:r>
             <a:endParaRPr lang="en-US" sz="1300" dirty="0"/>
           </a:p>
@@ -20990,7 +20990,7 @@
                 <a:ea typeface="Cormorant Garamond" pitchFamily="34" charset="-122"/>
                 <a:cs typeface="Cormorant Garamond" pitchFamily="34" charset="-120"/>
               </a:rPr>
-              <a:t>BG 3.3 · 4.33–38</a:t>
+              <a:t>BG 3.3 Â· 4.33â€“38</a:t>
             </a:r>
             <a:endParaRPr lang="en-US" sz="950" dirty="0"/>
           </a:p>
@@ -21032,7 +21032,7 @@
                 <a:ea typeface="Tiro Devanagari Sanskrit" pitchFamily="34" charset="-122"/>
                 <a:cs typeface="Tiro Devanagari Sanskrit" pitchFamily="34" charset="-120"/>
               </a:rPr>
-              <a:t>हरिं परं ज्ञात्वा, जीवं तदंशं, जगच्च तदधीनं सत्यं ज्ञात्वा प्रवृत्तिः। अधिकारिणां साधनम्।</a:t>
+              <a:t>à¤¹à¤°à¤¿à¤‚ à¤ªà¤°à¤‚ à¤œà¥à¤žà¤¾à¤¤à¥à¤µà¤¾, à¤œà¥€à¤µà¤‚ à¤¤à¤¦à¤‚à¤¶à¤‚, à¤œà¤—à¤šà¥à¤š à¤¤à¤¦à¤§à¥€à¤¨à¤‚ à¤¸à¤¤à¥à¤¯à¤‚ à¤œà¥à¤žà¤¾à¤¤à¥à¤µà¤¾ à¤ªà¥à¤°à¤µà¥ƒà¤¤à¥à¤¤à¤¿à¤ƒà¥¤ à¤…à¤§à¤¿à¤•à¤¾à¤°à¤¿à¤£à¤¾à¤‚ à¤¸à¤¾à¤§à¤¨à¤®à¥à¥¤</a:t>
             </a:r>
             <a:endParaRPr lang="en-US" sz="1050" dirty="0"/>
           </a:p>
@@ -21142,7 +21142,7 @@
                 <a:ea typeface="Tiro Devanagari Sanskrit" pitchFamily="34" charset="-122"/>
                 <a:cs typeface="Tiro Devanagari Sanskrit" pitchFamily="34" charset="-120"/>
               </a:rPr>
-              <a:t>साधना</a:t>
+              <a:t>à¤¸à¤¾à¤§à¤¨à¤¾</a:t>
             </a:r>
             <a:endParaRPr lang="en-US" sz="3000" dirty="0"/>
           </a:p>
@@ -21273,7 +21273,7 @@
                 <a:ea typeface="Tiro Devanagari Sanskrit" pitchFamily="34" charset="-122"/>
                 <a:cs typeface="Tiro Devanagari Sanskrit" pitchFamily="34" charset="-120"/>
               </a:rPr>
-              <a:t>श्रद्धा</a:t>
+              <a:t>à¤¶à¥à¤°à¤¦à¥à¤§à¤¾</a:t>
             </a:r>
             <a:endParaRPr lang="en-US" sz="1300" dirty="0"/>
           </a:p>
@@ -21312,7 +21312,7 @@
                 <a:ea typeface="Cormorant Garamond" pitchFamily="34" charset="-122"/>
                 <a:cs typeface="Cormorant Garamond" pitchFamily="34" charset="-120"/>
               </a:rPr>
-              <a:t>BG 17.2–3</a:t>
+              <a:t>BG 17.2â€“3</a:t>
             </a:r>
             <a:endParaRPr lang="en-US" sz="950" dirty="0"/>
           </a:p>
@@ -21354,7 +21354,7 @@
                 <a:ea typeface="Tiro Devanagari Sanskrit" pitchFamily="34" charset="-122"/>
                 <a:cs typeface="Tiro Devanagari Sanskrit" pitchFamily="34" charset="-120"/>
               </a:rPr>
-              <a:t>श्रद्धा स्वभावानुगा — यो यच्छ्रद्धः स एव सः। गुणतस्त्रिविधा — देवेषु सात्त्विकी, यक्षरक्षःसु राजसी, भूतप्रेतेषु तामसी।</a:t>
+              <a:t>à¤¶à¥à¤°à¤¦à¥à¤§à¤¾ à¤¸à¥à¤µà¤­à¤¾à¤µà¤¾à¤¨à¥à¤—à¤¾ â€” à¤¯à¥‹ à¤¯à¤šà¥à¤›à¥à¤°à¤¦à¥à¤§à¤ƒ à¤¸ à¤à¤µ à¤¸à¤ƒà¥¤ à¤—à¥à¤£à¤¤à¤¸à¥à¤¤à¥à¤°à¤¿à¤µà¤¿à¤§à¤¾ â€” à¤¦à¥‡à¤µà¥‡à¤·à¥ à¤¸à¤¾à¤¤à¥à¤¤à¥à¤µà¤¿à¤•à¥€, à¤¯à¤•à¥à¤·à¤°à¤•à¥à¤·à¤ƒà¤¸à¥ à¤°à¤¾à…</a:t>
             </a:r>
             <a:endParaRPr lang="en-US" sz="1050" dirty="0"/>
           </a:p>
@@ -21443,7 +21443,7 @@
                 <a:ea typeface="Tiro Devanagari Sanskrit" pitchFamily="34" charset="-122"/>
                 <a:cs typeface="Tiro Devanagari Sanskrit" pitchFamily="34" charset="-120"/>
               </a:rPr>
-              <a:t>वैराग्यम्</a:t>
+              <a:t>à¤µà¥ˆà¤°à¤¾à¤—à¥à¤¯à¤®à¥</a:t>
             </a:r>
             <a:endParaRPr lang="en-US" sz="1300" dirty="0"/>
           </a:p>
@@ -21482,7 +21482,7 @@
                 <a:ea typeface="Cormorant Garamond" pitchFamily="34" charset="-122"/>
                 <a:cs typeface="Cormorant Garamond" pitchFamily="34" charset="-120"/>
               </a:rPr>
-              <a:t>BG 6.35 · 13.8–11</a:t>
+              <a:t>BG 6.35 Â· 13.8â€“11</a:t>
             </a:r>
             <a:endParaRPr lang="en-US" sz="950" dirty="0"/>
           </a:p>
@@ -21524,7 +21524,7 @@
                 <a:ea typeface="Tiro Devanagari Sanskrit" pitchFamily="34" charset="-122"/>
                 <a:cs typeface="Tiro Devanagari Sanskrit" pitchFamily="34" charset="-120"/>
               </a:rPr>
-              <a:t>विषयेभ्यो विरक्तिः — न जीवननिषेधः, अपि तु बन्धनप्रदाकर्षणानां विवेकेन दर्शनम्।</a:t>
+              <a:t>à¤µà¤¿à¤·à¤¯à¥‡à¤­à¥à¤¯à¥‹ à¤µà¤¿à¤°à¤•à¥à¤¤à¤¿à¤ƒ â€” à¤¨ à¤œà¥€à¤µà¤¨à¤¨à¤¿à¤·à¥‡à¤§à¤ƒ, à¤…à¤ªà¤¿ à¤¤à¥ à¤¬à¤¨à¥à¤§à¤¨à¤ªà¥à¤°à¤¦à¤¾à¤•à¤°à¥à¤·à¤£à¤¾à¤¨à¤¾à¤‚ à¤µà¤¿à¤µà¥‡à¤•à¥‡à¤¨ à¤¦à¤°à¥à¤¶à¤¨à¤®à¥à¥¤</a:t>
             </a:r>
             <a:endParaRPr lang="en-US" sz="1050" dirty="0"/>
           </a:p>
@@ -21613,7 +21613,7 @@
                 <a:ea typeface="Tiro Devanagari Sanskrit" pitchFamily="34" charset="-122"/>
                 <a:cs typeface="Tiro Devanagari Sanskrit" pitchFamily="34" charset="-120"/>
               </a:rPr>
-              <a:t>अभ्यासः</a:t>
+              <a:t>à¤…à¤­à¥à¤¯à¤¾à¤¸à¤ƒ</a:t>
             </a:r>
             <a:endParaRPr lang="en-US" sz="1300" dirty="0"/>
           </a:p>
@@ -21652,7 +21652,7 @@
                 <a:ea typeface="Cormorant Garamond" pitchFamily="34" charset="-122"/>
                 <a:cs typeface="Cormorant Garamond" pitchFamily="34" charset="-120"/>
               </a:rPr>
-              <a:t>BG 6.26 · 12.9</a:t>
+              <a:t>BG 6.26 Â· 12.9</a:t>
             </a:r>
             <a:endParaRPr lang="en-US" sz="950" dirty="0"/>
           </a:p>
@@ -21694,7 +21694,7 @@
                 <a:ea typeface="Tiro Devanagari Sanskrit" pitchFamily="34" charset="-122"/>
                 <a:cs typeface="Tiro Devanagari Sanskrit" pitchFamily="34" charset="-120"/>
               </a:rPr>
-              <a:t>समाध्यभ्यासः — चञ्चलं मनः पुनःपुनः निवर्त्य हरौ नियमनम्।</a:t>
+              <a:t>à¤¸à¤®à¤¾à¤§à¥à¤¯à¤­à¥à¤¯à¤¾à¤¸à¤ƒ â€” à¤šà¤žà¥à¤šà¤²à¤‚ à¤®à¤¨à¤ƒ à¤ªà¥à¤¨à¤ƒà¤ªà¥à¤¨à¤ƒ à¤¨à¤¿à¤µà¤°à¥à¤¤à¥à¤¯ à¤¹à¤°à¥Œ à¤¨à¤¿à¤¯à¤®à¤¨à¤®à¥à¥¤</a:t>
             </a:r>
             <a:endParaRPr lang="en-US" sz="1050" dirty="0"/>
           </a:p>
@@ -21783,7 +21783,7 @@
                 <a:ea typeface="Tiro Devanagari Sanskrit" pitchFamily="34" charset="-122"/>
                 <a:cs typeface="Tiro Devanagari Sanskrit" pitchFamily="34" charset="-120"/>
               </a:rPr>
-              <a:t>तपः (त्रिविधम्)</a:t>
+              <a:t>à¤¤à¤ªà¤ƒ (à¤¤à¥à¤°à¤¿à¤µà¤¿à¤§à¤®à¥)</a:t>
             </a:r>
             <a:endParaRPr lang="en-US" sz="1300" dirty="0"/>
           </a:p>
@@ -21822,7 +21822,7 @@
                 <a:ea typeface="Cormorant Garamond" pitchFamily="34" charset="-122"/>
                 <a:cs typeface="Cormorant Garamond" pitchFamily="34" charset="-120"/>
               </a:rPr>
-              <a:t>BG 17.14–19</a:t>
+              <a:t>BG 17.14â€“19</a:t>
             </a:r>
             <a:endParaRPr lang="en-US" sz="950" dirty="0"/>
           </a:p>
@@ -21864,7 +21864,7 @@
                 <a:ea typeface="Tiro Devanagari Sanskrit" pitchFamily="34" charset="-122"/>
                 <a:cs typeface="Tiro Devanagari Sanskrit" pitchFamily="34" charset="-120"/>
               </a:rPr>
-              <a:t>देहस्य तपः (पूजा/शौच/ब्रह्मचर्य), वाचिकं (सत्य/प्रिय/स्वाध्याय), मानसिकं (प्रसाद/मौन/आत्मनिग्रह)। त्रयं गुणभेदात् त्रिविधम्।</a:t>
+              <a:t>à¤¦à¥‡à¤¹à¤¸à¥à¤¯ à¤¤à¤ªà¤ƒ (à¤ªà¥‚à¤œà¤¾/à¤¶à¥Œà¤š/à¤¬à¥à¤°à¤¹à¥à¤®à¤šà¤°à¥à¤¯), à¤µà¤¾à¤šà¤¿à¤•à¤‚ (à¤¸à¤¤à¥à¤¯/à¤ªà¥à¤°à¤¿à¤¯/à¤¸à¥à¤µà¤¾à¤§à¥à¤¯à¤¾à¤¯), à¤®à¤¾à¤¨à¤¸à¤¿à¤•à¤‚ (à¤ªà¥à¤°à¤¸à¤¾à¤¦/à¤®à¥Œà¤¨/à¤†à¤¤à¥à¤®à¤¨à¤¿à¤—à¥à¤°à¤¹)à¥¤ à¤¤à¥…</a:t>
             </a:r>
             <a:endParaRPr lang="en-US" sz="1050" dirty="0"/>
           </a:p>

</xml_diff>